<commit_message>
style(presentation): polish deck — flat shapes, no hero-metric cards, contrast, typography
Removes theme drop shadows from every shape; replaces big-number cards (novelty, results, closing)
with an editorial statement, arm-coloured before->after values, and a sentence-form close; fixes
tracker/source/green-text contrast to WCAG AA; true minus signs, en dashes and middot separators;
fixes title/member-tag and control-row overlaps; reserves crimson for the key finding.

Co-Authored-By: Claude Opus 5.5 <noreply@anthropic.com>
</commit_message>
<xml_diff>
--- a/presentation/final_presentation.pptx
+++ b/presentation/final_presentation.pptx
@@ -4381,20 +4381,6 @@
             <a:noFill/>
           </a:ln>
         </p:spPr>
-        <p:style>
-          <a:lnRef idx="1">
-            <a:schemeClr val="accent1"/>
-          </a:lnRef>
-          <a:fillRef idx="3">
-            <a:schemeClr val="accent1"/>
-          </a:fillRef>
-          <a:effectRef idx="2">
-            <a:schemeClr val="accent1"/>
-          </a:effectRef>
-          <a:fontRef idx="minor">
-            <a:schemeClr val="lt1"/>
-          </a:fontRef>
-        </p:style>
         <p:txBody>
           <a:bodyPr rtlCol="0" anchor="ctr"/>
           <a:lstStyle/>
@@ -4527,7 +4513,7 @@
                 </a:solidFill>
                 <a:latin typeface="Arial"/>
               </a:rPr>
-              <a:t>CSE 4883 Digital Image Processing - final presentation</a:t>
+              <a:t>CSE 4883 Digital Image Processing  ·  final presentation</a:t>
             </a:r>
           </a:p>
           <a:p>
@@ -4543,7 +4529,7 @@
                 </a:solidFill>
                 <a:latin typeface="Arial"/>
               </a:rPr>
-              <a:t>Member 1 - Member 2 - Member 3</a:t>
+              <a:t>Member 1  ·  Member 2  ·  Member 3</a:t>
             </a:r>
           </a:p>
         </p:txBody>
@@ -4578,7 +4564,7 @@
                 </a:solidFill>
                 <a:latin typeface="Arial"/>
               </a:rPr>
-              <a:t>Introduction  -  Novelty  -  Methodology  -  Experiments  -  Results  -  Limitations  -  Future</a:t>
+              <a:t>Introduction   ·   Novelty   ·   Methodology   ·   Experiments   ·   Results   ·   Limitations   ·   Future</a:t>
             </a:r>
           </a:p>
         </p:txBody>
@@ -4627,7 +4613,7 @@
             <a:r>
               <a:rPr sz="1050" b="0" i="0">
                 <a:solidFill>
-                  <a:srgbClr val="A9B4C0"/>
+                  <a:srgbClr val="5D6D7E"/>
                 </a:solidFill>
                 <a:latin typeface="Arial"/>
               </a:rPr>
@@ -4662,7 +4648,7 @@
             <a:r>
               <a:rPr sz="1050" b="0" i="0">
                 <a:solidFill>
-                  <a:srgbClr val="A9B4C0"/>
+                  <a:srgbClr val="5D6D7E"/>
                 </a:solidFill>
                 <a:latin typeface="Arial"/>
               </a:rPr>
@@ -4697,7 +4683,7 @@
             <a:r>
               <a:rPr sz="1050" b="0" i="0">
                 <a:solidFill>
-                  <a:srgbClr val="A9B4C0"/>
+                  <a:srgbClr val="5D6D7E"/>
                 </a:solidFill>
                 <a:latin typeface="Arial"/>
               </a:rPr>
@@ -4732,7 +4718,7 @@
             <a:r>
               <a:rPr sz="1050" b="0" i="0">
                 <a:solidFill>
-                  <a:srgbClr val="A9B4C0"/>
+                  <a:srgbClr val="5D6D7E"/>
                 </a:solidFill>
                 <a:latin typeface="Arial"/>
               </a:rPr>
@@ -4797,20 +4783,6 @@
             <a:noFill/>
           </a:ln>
         </p:spPr>
-        <p:style>
-          <a:lnRef idx="1">
-            <a:schemeClr val="accent1"/>
-          </a:lnRef>
-          <a:fillRef idx="3">
-            <a:schemeClr val="accent1"/>
-          </a:fillRef>
-          <a:effectRef idx="2">
-            <a:schemeClr val="accent1"/>
-          </a:effectRef>
-          <a:fontRef idx="minor">
-            <a:schemeClr val="lt1"/>
-          </a:fontRef>
-        </p:style>
         <p:txBody>
           <a:bodyPr rtlCol="0" anchor="ctr"/>
           <a:lstStyle/>
@@ -4845,7 +4817,7 @@
             <a:r>
               <a:rPr sz="1050" b="0" i="0">
                 <a:solidFill>
-                  <a:srgbClr val="A9B4C0"/>
+                  <a:srgbClr val="5D6D7E"/>
                 </a:solidFill>
                 <a:latin typeface="Arial"/>
               </a:rPr>
@@ -4880,7 +4852,7 @@
             <a:r>
               <a:rPr sz="1050" b="0" i="0">
                 <a:solidFill>
-                  <a:srgbClr val="A9B4C0"/>
+                  <a:srgbClr val="5D6D7E"/>
                 </a:solidFill>
                 <a:latin typeface="Arial"/>
               </a:rPr>
@@ -4910,20 +4882,6 @@
             <a:noFill/>
           </a:ln>
         </p:spPr>
-        <p:style>
-          <a:lnRef idx="1">
-            <a:schemeClr val="accent1"/>
-          </a:lnRef>
-          <a:fillRef idx="3">
-            <a:schemeClr val="accent1"/>
-          </a:fillRef>
-          <a:effectRef idx="2">
-            <a:schemeClr val="accent1"/>
-          </a:effectRef>
-          <a:fontRef idx="minor">
-            <a:schemeClr val="lt1"/>
-          </a:fontRef>
-        </p:style>
         <p:txBody>
           <a:bodyPr rtlCol="0" anchor="ctr"/>
           <a:lstStyle/>
@@ -4941,7 +4899,7 @@
         <p:spPr>
           <a:xfrm>
             <a:off x="548640" y="713232"/>
-            <a:ext cx="9509760" cy="548640"/>
+            <a:ext cx="9418320" cy="548640"/>
           </a:xfrm>
           <a:prstGeom prst="rect">
             <a:avLst/>
@@ -4975,8 +4933,8 @@
         </p:nvSpPr>
         <p:spPr>
           <a:xfrm>
-            <a:off x="9997135" y="822960"/>
-            <a:ext cx="1645920" cy="274320"/>
+            <a:off x="10271455" y="822960"/>
+            <a:ext cx="1371600" cy="274320"/>
           </a:xfrm>
           <a:prstGeom prst="rect">
             <a:avLst/>
@@ -5033,214 +4991,217 @@
       </p:pic>
       <p:sp>
         <p:nvSpPr>
-          <p:cNvPr id="14" name="Rounded Rectangle 13"/>
-          <p:cNvSpPr/>
+          <p:cNvPr id="14" name="TextBox 13"/>
+          <p:cNvSpPr txBox="1"/>
           <p:nvPr/>
         </p:nvSpPr>
         <p:spPr>
           <a:xfrm>
             <a:off x="548640" y="5440680"/>
-            <a:ext cx="3515258" cy="822960"/>
-          </a:xfrm>
-          <a:prstGeom prst="roundRect">
-            <a:avLst>
-              <a:gd name="adj" fmla="val 12000"/>
-            </a:avLst>
-          </a:prstGeom>
-          <a:solidFill>
-            <a:srgbClr val="FFFFFF"/>
-          </a:solidFill>
-          <a:ln w="19050">
-            <a:solidFill>
-              <a:srgbClr val="1F3A5F"/>
-            </a:solidFill>
-          </a:ln>
-          <a:effectLst/>
-        </p:spPr>
-        <p:style>
-          <a:lnRef idx="1">
-            <a:schemeClr val="accent1"/>
-          </a:lnRef>
-          <a:fillRef idx="3">
-            <a:schemeClr val="accent1"/>
-          </a:fillRef>
-          <a:effectRef idx="2">
-            <a:schemeClr val="accent1"/>
-          </a:effectRef>
-          <a:fontRef idx="minor">
-            <a:schemeClr val="lt1"/>
-          </a:fontRef>
-        </p:style>
-        <p:txBody>
-          <a:bodyPr rtlCol="0" anchor="ctr" wrap="square" lIns="73152" rIns="73152" tIns="27432" bIns="27432"/>
+            <a:ext cx="3698138" cy="274320"/>
+          </a:xfrm>
+          <a:prstGeom prst="rect">
+            <a:avLst/>
+          </a:prstGeom>
+          <a:noFill/>
+        </p:spPr>
+        <p:txBody>
+          <a:bodyPr wrap="square" lIns="0" rIns="0" tIns="0" bIns="0">
+            <a:spAutoFit/>
+          </a:bodyPr>
           <a:lstStyle/>
           <a:p>
             <a:pPr algn="ctr"/>
             <a:r>
-              <a:rPr sz="2200" b="1">
-                <a:solidFill>
-                  <a:srgbClr val="1F3A5F"/>
+              <a:rPr sz="1250" b="0" i="0">
+                <a:solidFill>
+                  <a:srgbClr val="5D6D7E"/>
+                </a:solidFill>
+                <a:latin typeface="Arial"/>
+              </a:rPr>
+              <a:t>Pooled  ·  combined arm</a:t>
+            </a:r>
+          </a:p>
+        </p:txBody>
+      </p:sp>
+      <p:sp>
+        <p:nvSpPr>
+          <p:cNvPr id="15" name="TextBox 14"/>
+          <p:cNvSpPr txBox="1"/>
+          <p:nvPr/>
+        </p:nvSpPr>
+        <p:spPr>
+          <a:xfrm>
+            <a:off x="548640" y="5715000"/>
+            <a:ext cx="3698138" cy="457200"/>
+          </a:xfrm>
+          <a:prstGeom prst="rect">
+            <a:avLst/>
+          </a:prstGeom>
+          <a:noFill/>
+        </p:spPr>
+        <p:txBody>
+          <a:bodyPr wrap="square" lIns="0" rIns="0" tIns="0" bIns="0">
+            <a:spAutoFit/>
+          </a:bodyPr>
+          <a:lstStyle/>
+          <a:p>
+            <a:pPr algn="ctr"/>
+            <a:r>
+              <a:rPr sz="2400" b="1" i="0">
+                <a:solidFill>
+                  <a:srgbClr val="0E7A53"/>
                 </a:solidFill>
                 <a:latin typeface="Arial"/>
               </a:rPr>
               <a:t>0.796 → 0.802</a:t>
             </a:r>
           </a:p>
+        </p:txBody>
+      </p:sp>
+      <p:sp>
+        <p:nvSpPr>
+          <p:cNvPr id="16" name="TextBox 15"/>
+          <p:cNvSpPr txBox="1"/>
+          <p:nvPr/>
+        </p:nvSpPr>
+        <p:spPr>
+          <a:xfrm>
+            <a:off x="4246778" y="5440680"/>
+            <a:ext cx="3698138" cy="274320"/>
+          </a:xfrm>
+          <a:prstGeom prst="rect">
+            <a:avLst/>
+          </a:prstGeom>
+          <a:noFill/>
+        </p:spPr>
+        <p:txBody>
+          <a:bodyPr wrap="square" lIns="0" rIns="0" tIns="0" bIns="0">
+            <a:spAutoFit/>
+          </a:bodyPr>
+          <a:lstStyle/>
           <a:p>
             <a:pPr algn="ctr"/>
             <a:r>
-              <a:rPr sz="1250" b="0">
+              <a:rPr sz="1250" b="0" i="0">
                 <a:solidFill>
                   <a:srgbClr val="5D6D7E"/>
                 </a:solidFill>
                 <a:latin typeface="Arial"/>
               </a:rPr>
-              <a:t>Pooled (combined)</a:t>
-            </a:r>
-          </a:p>
-        </p:txBody>
-      </p:sp>
-      <p:sp>
-        <p:nvSpPr>
-          <p:cNvPr id="15" name="Rounded Rectangle 14"/>
-          <p:cNvSpPr/>
-          <p:nvPr/>
-        </p:nvSpPr>
-        <p:spPr>
-          <a:xfrm>
-            <a:off x="4338218" y="5440680"/>
-            <a:ext cx="3515258" cy="822960"/>
-          </a:xfrm>
-          <a:prstGeom prst="roundRect">
-            <a:avLst>
-              <a:gd name="adj" fmla="val 12000"/>
-            </a:avLst>
-          </a:prstGeom>
-          <a:solidFill>
-            <a:srgbClr val="FFFFFF"/>
-          </a:solidFill>
-          <a:ln w="19050">
-            <a:solidFill>
-              <a:srgbClr val="B2182B"/>
-            </a:solidFill>
-          </a:ln>
-          <a:effectLst/>
-        </p:spPr>
-        <p:style>
-          <a:lnRef idx="1">
-            <a:schemeClr val="accent1"/>
-          </a:lnRef>
-          <a:fillRef idx="3">
-            <a:schemeClr val="accent1"/>
-          </a:fillRef>
-          <a:effectRef idx="2">
-            <a:schemeClr val="accent1"/>
-          </a:effectRef>
-          <a:fontRef idx="minor">
-            <a:schemeClr val="lt1"/>
-          </a:fontRef>
-        </p:style>
-        <p:txBody>
-          <a:bodyPr rtlCol="0" anchor="ctr" wrap="square" lIns="73152" rIns="73152" tIns="27432" bIns="27432"/>
+              <a:t>BigGAN  ·  frequency arm</a:t>
+            </a:r>
+          </a:p>
+        </p:txBody>
+      </p:sp>
+      <p:sp>
+        <p:nvSpPr>
+          <p:cNvPr id="17" name="TextBox 16"/>
+          <p:cNvSpPr txBox="1"/>
+          <p:nvPr/>
+        </p:nvSpPr>
+        <p:spPr>
+          <a:xfrm>
+            <a:off x="4246778" y="5715000"/>
+            <a:ext cx="3698138" cy="457200"/>
+          </a:xfrm>
+          <a:prstGeom prst="rect">
+            <a:avLst/>
+          </a:prstGeom>
+          <a:noFill/>
+        </p:spPr>
+        <p:txBody>
+          <a:bodyPr wrap="square" lIns="0" rIns="0" tIns="0" bIns="0">
+            <a:spAutoFit/>
+          </a:bodyPr>
           <a:lstStyle/>
           <a:p>
             <a:pPr algn="ctr"/>
             <a:r>
-              <a:rPr sz="2200" b="1">
-                <a:solidFill>
-                  <a:srgbClr val="B2182B"/>
+              <a:rPr sz="2400" b="1" i="0">
+                <a:solidFill>
+                  <a:srgbClr val="B54819"/>
                 </a:solidFill>
                 <a:latin typeface="Arial"/>
               </a:rPr>
               <a:t>1.000 → 0.828</a:t>
             </a:r>
           </a:p>
+        </p:txBody>
+      </p:sp>
+      <p:sp>
+        <p:nvSpPr>
+          <p:cNvPr id="18" name="TextBox 17"/>
+          <p:cNvSpPr txBox="1"/>
+          <p:nvPr/>
+        </p:nvSpPr>
+        <p:spPr>
+          <a:xfrm>
+            <a:off x="7944916" y="5440680"/>
+            <a:ext cx="3698138" cy="274320"/>
+          </a:xfrm>
+          <a:prstGeom prst="rect">
+            <a:avLst/>
+          </a:prstGeom>
+          <a:noFill/>
+        </p:spPr>
+        <p:txBody>
+          <a:bodyPr wrap="square" lIns="0" rIns="0" tIns="0" bIns="0">
+            <a:spAutoFit/>
+          </a:bodyPr>
+          <a:lstStyle/>
           <a:p>
             <a:pPr algn="ctr"/>
             <a:r>
-              <a:rPr sz="1250" b="0">
+              <a:rPr sz="1250" b="0" i="0">
                 <a:solidFill>
                   <a:srgbClr val="5D6D7E"/>
                 </a:solidFill>
                 <a:latin typeface="Arial"/>
               </a:rPr>
-              <a:t>BigGAN (frequency)</a:t>
-            </a:r>
-          </a:p>
-        </p:txBody>
-      </p:sp>
-      <p:sp>
-        <p:nvSpPr>
-          <p:cNvPr id="16" name="Rounded Rectangle 15"/>
-          <p:cNvSpPr/>
-          <p:nvPr/>
-        </p:nvSpPr>
-        <p:spPr>
-          <a:xfrm>
-            <a:off x="8127796" y="5440680"/>
-            <a:ext cx="3515258" cy="822960"/>
-          </a:xfrm>
-          <a:prstGeom prst="roundRect">
-            <a:avLst>
-              <a:gd name="adj" fmla="val 12000"/>
-            </a:avLst>
-          </a:prstGeom>
-          <a:solidFill>
-            <a:srgbClr val="FFFFFF"/>
-          </a:solidFill>
-          <a:ln w="19050">
-            <a:solidFill>
-              <a:srgbClr val="1BAF7A"/>
-            </a:solidFill>
-          </a:ln>
-          <a:effectLst/>
-        </p:spPr>
-        <p:style>
-          <a:lnRef idx="1">
-            <a:schemeClr val="accent1"/>
-          </a:lnRef>
-          <a:fillRef idx="3">
-            <a:schemeClr val="accent1"/>
-          </a:fillRef>
-          <a:effectRef idx="2">
-            <a:schemeClr val="accent1"/>
-          </a:effectRef>
-          <a:fontRef idx="minor">
-            <a:schemeClr val="lt1"/>
-          </a:fontRef>
-        </p:style>
-        <p:txBody>
-          <a:bodyPr rtlCol="0" anchor="ctr" wrap="square" lIns="73152" rIns="73152" tIns="27432" bIns="27432"/>
+              <a:t>Unseen SD v1.4  ·  pixel arm</a:t>
+            </a:r>
+          </a:p>
+        </p:txBody>
+      </p:sp>
+      <p:sp>
+        <p:nvSpPr>
+          <p:cNvPr id="19" name="TextBox 18"/>
+          <p:cNvSpPr txBox="1"/>
+          <p:nvPr/>
+        </p:nvSpPr>
+        <p:spPr>
+          <a:xfrm>
+            <a:off x="7944916" y="5715000"/>
+            <a:ext cx="3698138" cy="457200"/>
+          </a:xfrm>
+          <a:prstGeom prst="rect">
+            <a:avLst/>
+          </a:prstGeom>
+          <a:noFill/>
+        </p:spPr>
+        <p:txBody>
+          <a:bodyPr wrap="square" lIns="0" rIns="0" tIns="0" bIns="0">
+            <a:spAutoFit/>
+          </a:bodyPr>
           <a:lstStyle/>
           <a:p>
             <a:pPr algn="ctr"/>
             <a:r>
-              <a:rPr sz="2200" b="1">
-                <a:solidFill>
-                  <a:srgbClr val="1BAF7A"/>
+              <a:rPr sz="2400" b="1" i="0">
+                <a:solidFill>
+                  <a:srgbClr val="1F63B8"/>
                 </a:solidFill>
                 <a:latin typeface="Arial"/>
               </a:rPr>
               <a:t>0.477 → 0.771</a:t>
             </a:r>
           </a:p>
-          <a:p>
-            <a:pPr algn="ctr"/>
-            <a:r>
-              <a:rPr sz="1250" b="0">
-                <a:solidFill>
-                  <a:srgbClr val="5D6D7E"/>
-                </a:solidFill>
-                <a:latin typeface="Arial"/>
-              </a:rPr>
-              <a:t>Unseen SD v1.4 (pixel)</a:t>
-            </a:r>
-          </a:p>
-        </p:txBody>
-      </p:sp>
-      <p:sp>
-        <p:nvSpPr>
-          <p:cNvPr id="17" name="TextBox 16"/>
+        </p:txBody>
+      </p:sp>
+      <p:sp>
+        <p:nvSpPr>
+          <p:cNvPr id="20" name="TextBox 19"/>
           <p:cNvSpPr txBox="1"/>
           <p:nvPr/>
         </p:nvSpPr>
@@ -5268,14 +5229,14 @@
                 </a:solidFill>
                 <a:latin typeface="Arial"/>
               </a:rPr>
-              <a:t>Same score, different story - spatial-frequency features for AI-generated image detection</a:t>
-            </a:r>
-          </a:p>
-        </p:txBody>
-      </p:sp>
-      <p:sp>
-        <p:nvSpPr>
-          <p:cNvPr id="18" name="TextBox 17"/>
+              <a:t>CSE 4883 Digital Image Processing  ·  Same score, different story</a:t>
+            </a:r>
+          </a:p>
+        </p:txBody>
+      </p:sp>
+      <p:sp>
+        <p:nvSpPr>
+          <p:cNvPr id="21" name="TextBox 20"/>
           <p:cNvSpPr txBox="1"/>
           <p:nvPr/>
         </p:nvSpPr>
@@ -5352,7 +5313,7 @@
             <a:r>
               <a:rPr sz="1050" b="0" i="0">
                 <a:solidFill>
-                  <a:srgbClr val="A9B4C0"/>
+                  <a:srgbClr val="5D6D7E"/>
                 </a:solidFill>
                 <a:latin typeface="Arial"/>
               </a:rPr>
@@ -5387,7 +5348,7 @@
             <a:r>
               <a:rPr sz="1050" b="0" i="0">
                 <a:solidFill>
-                  <a:srgbClr val="A9B4C0"/>
+                  <a:srgbClr val="5D6D7E"/>
                 </a:solidFill>
                 <a:latin typeface="Arial"/>
               </a:rPr>
@@ -5422,7 +5383,7 @@
             <a:r>
               <a:rPr sz="1050" b="0" i="0">
                 <a:solidFill>
-                  <a:srgbClr val="A9B4C0"/>
+                  <a:srgbClr val="5D6D7E"/>
                 </a:solidFill>
                 <a:latin typeface="Arial"/>
               </a:rPr>
@@ -5457,7 +5418,7 @@
             <a:r>
               <a:rPr sz="1050" b="0" i="0">
                 <a:solidFill>
-                  <a:srgbClr val="A9B4C0"/>
+                  <a:srgbClr val="5D6D7E"/>
                 </a:solidFill>
                 <a:latin typeface="Arial"/>
               </a:rPr>
@@ -5522,20 +5483,6 @@
             <a:noFill/>
           </a:ln>
         </p:spPr>
-        <p:style>
-          <a:lnRef idx="1">
-            <a:schemeClr val="accent1"/>
-          </a:lnRef>
-          <a:fillRef idx="3">
-            <a:schemeClr val="accent1"/>
-          </a:fillRef>
-          <a:effectRef idx="2">
-            <a:schemeClr val="accent1"/>
-          </a:effectRef>
-          <a:fontRef idx="minor">
-            <a:schemeClr val="lt1"/>
-          </a:fontRef>
-        </p:style>
         <p:txBody>
           <a:bodyPr rtlCol="0" anchor="ctr"/>
           <a:lstStyle/>
@@ -5570,7 +5517,7 @@
             <a:r>
               <a:rPr sz="1050" b="0" i="0">
                 <a:solidFill>
-                  <a:srgbClr val="A9B4C0"/>
+                  <a:srgbClr val="5D6D7E"/>
                 </a:solidFill>
                 <a:latin typeface="Arial"/>
               </a:rPr>
@@ -5605,7 +5552,7 @@
             <a:r>
               <a:rPr sz="1050" b="0" i="0">
                 <a:solidFill>
-                  <a:srgbClr val="A9B4C0"/>
+                  <a:srgbClr val="5D6D7E"/>
                 </a:solidFill>
                 <a:latin typeface="Arial"/>
               </a:rPr>
@@ -5635,20 +5582,6 @@
             <a:noFill/>
           </a:ln>
         </p:spPr>
-        <p:style>
-          <a:lnRef idx="1">
-            <a:schemeClr val="accent1"/>
-          </a:lnRef>
-          <a:fillRef idx="3">
-            <a:schemeClr val="accent1"/>
-          </a:fillRef>
-          <a:effectRef idx="2">
-            <a:schemeClr val="accent1"/>
-          </a:effectRef>
-          <a:fontRef idx="minor">
-            <a:schemeClr val="lt1"/>
-          </a:fontRef>
-        </p:style>
         <p:txBody>
           <a:bodyPr rtlCol="0" anchor="ctr"/>
           <a:lstStyle/>
@@ -5666,7 +5599,7 @@
         <p:spPr>
           <a:xfrm>
             <a:off x="548640" y="713232"/>
-            <a:ext cx="9509760" cy="548640"/>
+            <a:ext cx="9418320" cy="548640"/>
           </a:xfrm>
           <a:prstGeom prst="rect">
             <a:avLst/>
@@ -5700,8 +5633,8 @@
         </p:nvSpPr>
         <p:spPr>
           <a:xfrm>
-            <a:off x="9997135" y="822960"/>
-            <a:ext cx="1645920" cy="274320"/>
+            <a:off x="10271455" y="822960"/>
+            <a:ext cx="1371600" cy="274320"/>
           </a:xfrm>
           <a:prstGeom prst="rect">
             <a:avLst/>
@@ -5825,7 +5758,7 @@
                 </a:solidFill>
                 <a:latin typeface="Arial"/>
               </a:rPr>
-              <a:t>Which arm looks stronger?  pixel - frequency</a:t>
+              <a:t>Which arm looks stronger?  pixel − frequency</a:t>
             </a:r>
           </a:p>
         </p:txBody>
@@ -5952,7 +5885,7 @@
                           </a:solidFill>
                           <a:latin typeface="Arial"/>
                         </a:rPr>
-                        <a:t>-0.088 [-0.130, -0.045]</a:t>
+                        <a:t>−0.088 [−0.130, −0.045]</a:t>
                       </a:r>
                     </a:p>
                   </a:txBody>
@@ -6010,7 +5943,7 @@
                           </a:solidFill>
                           <a:latin typeface="Arial"/>
                         </a:rPr>
-                        <a:t>+0.022 [-0.015, 0.056]</a:t>
+                        <a:t>+0.022 [−0.015, 0.056]</a:t>
                       </a:r>
                     </a:p>
                   </a:txBody>
@@ -6466,7 +6399,7 @@
                 </a:solidFill>
                 <a:latin typeface="Arial"/>
               </a:rPr>
-              <a:t>Same score, different story - spatial-frequency features for AI-generated image detection</a:t>
+              <a:t>CSE 4883 Digital Image Processing  ·  Same score, different story</a:t>
             </a:r>
           </a:p>
         </p:txBody>
@@ -6550,7 +6483,7 @@
             <a:r>
               <a:rPr sz="1050" b="0" i="0">
                 <a:solidFill>
-                  <a:srgbClr val="A9B4C0"/>
+                  <a:srgbClr val="5D6D7E"/>
                 </a:solidFill>
                 <a:latin typeface="Arial"/>
               </a:rPr>
@@ -6585,7 +6518,7 @@
             <a:r>
               <a:rPr sz="1050" b="0" i="0">
                 <a:solidFill>
-                  <a:srgbClr val="A9B4C0"/>
+                  <a:srgbClr val="5D6D7E"/>
                 </a:solidFill>
                 <a:latin typeface="Arial"/>
               </a:rPr>
@@ -6620,7 +6553,7 @@
             <a:r>
               <a:rPr sz="1050" b="0" i="0">
                 <a:solidFill>
-                  <a:srgbClr val="A9B4C0"/>
+                  <a:srgbClr val="5D6D7E"/>
                 </a:solidFill>
                 <a:latin typeface="Arial"/>
               </a:rPr>
@@ -6655,7 +6588,7 @@
             <a:r>
               <a:rPr sz="1050" b="0" i="0">
                 <a:solidFill>
-                  <a:srgbClr val="A9B4C0"/>
+                  <a:srgbClr val="5D6D7E"/>
                 </a:solidFill>
                 <a:latin typeface="Arial"/>
               </a:rPr>
@@ -6690,7 +6623,7 @@
             <a:r>
               <a:rPr sz="1050" b="0" i="0">
                 <a:solidFill>
-                  <a:srgbClr val="A9B4C0"/>
+                  <a:srgbClr val="5D6D7E"/>
                 </a:solidFill>
                 <a:latin typeface="Arial"/>
               </a:rPr>
@@ -6755,20 +6688,6 @@
             <a:noFill/>
           </a:ln>
         </p:spPr>
-        <p:style>
-          <a:lnRef idx="1">
-            <a:schemeClr val="accent1"/>
-          </a:lnRef>
-          <a:fillRef idx="3">
-            <a:schemeClr val="accent1"/>
-          </a:fillRef>
-          <a:effectRef idx="2">
-            <a:schemeClr val="accent1"/>
-          </a:effectRef>
-          <a:fontRef idx="minor">
-            <a:schemeClr val="lt1"/>
-          </a:fontRef>
-        </p:style>
         <p:txBody>
           <a:bodyPr rtlCol="0" anchor="ctr"/>
           <a:lstStyle/>
@@ -6833,20 +6752,6 @@
             <a:noFill/>
           </a:ln>
         </p:spPr>
-        <p:style>
-          <a:lnRef idx="1">
-            <a:schemeClr val="accent1"/>
-          </a:lnRef>
-          <a:fillRef idx="3">
-            <a:schemeClr val="accent1"/>
-          </a:fillRef>
-          <a:effectRef idx="2">
-            <a:schemeClr val="accent1"/>
-          </a:effectRef>
-          <a:fontRef idx="minor">
-            <a:schemeClr val="lt1"/>
-          </a:fontRef>
-        </p:style>
         <p:txBody>
           <a:bodyPr rtlCol="0" anchor="ctr"/>
           <a:lstStyle/>
@@ -6876,20 +6781,6 @@
             <a:noFill/>
           </a:ln>
         </p:spPr>
-        <p:style>
-          <a:lnRef idx="1">
-            <a:schemeClr val="accent1"/>
-          </a:lnRef>
-          <a:fillRef idx="3">
-            <a:schemeClr val="accent1"/>
-          </a:fillRef>
-          <a:effectRef idx="2">
-            <a:schemeClr val="accent1"/>
-          </a:effectRef>
-          <a:fontRef idx="minor">
-            <a:schemeClr val="lt1"/>
-          </a:fontRef>
-        </p:style>
         <p:txBody>
           <a:bodyPr rtlCol="0" anchor="ctr"/>
           <a:lstStyle/>
@@ -6907,7 +6798,7 @@
         <p:spPr>
           <a:xfrm>
             <a:off x="548640" y="713232"/>
-            <a:ext cx="9509760" cy="548640"/>
+            <a:ext cx="9418320" cy="548640"/>
           </a:xfrm>
           <a:prstGeom prst="rect">
             <a:avLst/>
@@ -6941,8 +6832,8 @@
         </p:nvSpPr>
         <p:spPr>
           <a:xfrm>
-            <a:off x="9997135" y="822960"/>
-            <a:ext cx="1645920" cy="274320"/>
+            <a:off x="10271455" y="822960"/>
+            <a:ext cx="1371600" cy="274320"/>
           </a:xfrm>
           <a:prstGeom prst="rect">
             <a:avLst/>
@@ -7064,20 +6955,6 @@
           </a:ln>
           <a:effectLst/>
         </p:spPr>
-        <p:style>
-          <a:lnRef idx="1">
-            <a:schemeClr val="accent1"/>
-          </a:lnRef>
-          <a:fillRef idx="3">
-            <a:schemeClr val="accent1"/>
-          </a:fillRef>
-          <a:effectRef idx="2">
-            <a:schemeClr val="accent1"/>
-          </a:effectRef>
-          <a:fontRef idx="minor">
-            <a:schemeClr val="lt1"/>
-          </a:fontRef>
-        </p:style>
         <p:txBody>
           <a:bodyPr rtlCol="0" anchor="ctr" wrap="square" lIns="73152" rIns="73152" tIns="27432" bIns="27432"/>
           <a:lstStyle/>
@@ -7116,20 +6993,6 @@
             <a:tailEnd type="triangle" w="med" len="med"/>
           </a:ln>
         </p:spPr>
-        <p:style>
-          <a:lnRef idx="2">
-            <a:schemeClr val="accent1"/>
-          </a:lnRef>
-          <a:fillRef idx="0">
-            <a:schemeClr val="accent1"/>
-          </a:fillRef>
-          <a:effectRef idx="1">
-            <a:schemeClr val="accent1"/>
-          </a:effectRef>
-          <a:fontRef idx="minor">
-            <a:schemeClr val="tx1"/>
-          </a:fontRef>
-        </p:style>
       </p:cxnSp>
       <p:sp>
         <p:nvSpPr>
@@ -7157,20 +7020,6 @@
           </a:ln>
           <a:effectLst/>
         </p:spPr>
-        <p:style>
-          <a:lnRef idx="1">
-            <a:schemeClr val="accent1"/>
-          </a:lnRef>
-          <a:fillRef idx="3">
-            <a:schemeClr val="accent1"/>
-          </a:fillRef>
-          <a:effectRef idx="2">
-            <a:schemeClr val="accent1"/>
-          </a:effectRef>
-          <a:fontRef idx="minor">
-            <a:schemeClr val="lt1"/>
-          </a:fontRef>
-        </p:style>
         <p:txBody>
           <a:bodyPr rtlCol="0" anchor="ctr" wrap="square" lIns="73152" rIns="73152" tIns="27432" bIns="27432"/>
           <a:lstStyle/>
@@ -7183,7 +7032,7 @@
                 </a:solidFill>
                 <a:latin typeface="Arial"/>
               </a:rPr>
-              <a:t>pre-specified native-resolution protocol, matched field of view</a:t>
+              <a:t>pre-specified native-resolution protocol (matched view)</a:t>
             </a:r>
           </a:p>
         </p:txBody>
@@ -7214,20 +7063,6 @@
           </a:ln>
           <a:effectLst/>
         </p:spPr>
-        <p:style>
-          <a:lnRef idx="1">
-            <a:schemeClr val="accent1"/>
-          </a:lnRef>
-          <a:fillRef idx="3">
-            <a:schemeClr val="accent1"/>
-          </a:fillRef>
-          <a:effectRef idx="2">
-            <a:schemeClr val="accent1"/>
-          </a:effectRef>
-          <a:fontRef idx="minor">
-            <a:schemeClr val="lt1"/>
-          </a:fontRef>
-        </p:style>
         <p:txBody>
           <a:bodyPr rtlCol="0" anchor="ctr" wrap="square" lIns="73152" rIns="73152" tIns="27432" bIns="27432"/>
           <a:lstStyle/>
@@ -7266,20 +7101,6 @@
             <a:tailEnd type="triangle" w="med" len="med"/>
           </a:ln>
         </p:spPr>
-        <p:style>
-          <a:lnRef idx="2">
-            <a:schemeClr val="accent1"/>
-          </a:lnRef>
-          <a:fillRef idx="0">
-            <a:schemeClr val="accent1"/>
-          </a:fillRef>
-          <a:effectRef idx="1">
-            <a:schemeClr val="accent1"/>
-          </a:effectRef>
-          <a:fontRef idx="minor">
-            <a:schemeClr val="tx1"/>
-          </a:fontRef>
-        </p:style>
       </p:cxnSp>
       <p:sp>
         <p:nvSpPr>
@@ -7307,20 +7128,6 @@
           </a:ln>
           <a:effectLst/>
         </p:spPr>
-        <p:style>
-          <a:lnRef idx="1">
-            <a:schemeClr val="accent1"/>
-          </a:lnRef>
-          <a:fillRef idx="3">
-            <a:schemeClr val="accent1"/>
-          </a:fillRef>
-          <a:effectRef idx="2">
-            <a:schemeClr val="accent1"/>
-          </a:effectRef>
-          <a:fontRef idx="minor">
-            <a:schemeClr val="lt1"/>
-          </a:fontRef>
-        </p:style>
         <p:txBody>
           <a:bodyPr rtlCol="0" anchor="ctr" wrap="square" lIns="73152" rIns="73152" tIns="27432" bIns="27432"/>
           <a:lstStyle/>
@@ -7364,20 +7171,6 @@
           </a:ln>
           <a:effectLst/>
         </p:spPr>
-        <p:style>
-          <a:lnRef idx="1">
-            <a:schemeClr val="accent1"/>
-          </a:lnRef>
-          <a:fillRef idx="3">
-            <a:schemeClr val="accent1"/>
-          </a:fillRef>
-          <a:effectRef idx="2">
-            <a:schemeClr val="accent1"/>
-          </a:effectRef>
-          <a:fontRef idx="minor">
-            <a:schemeClr val="lt1"/>
-          </a:fontRef>
-        </p:style>
         <p:txBody>
           <a:bodyPr rtlCol="0" anchor="ctr" wrap="square" lIns="73152" rIns="73152" tIns="27432" bIns="27432"/>
           <a:lstStyle/>
@@ -7416,20 +7209,6 @@
             <a:tailEnd type="triangle" w="med" len="med"/>
           </a:ln>
         </p:spPr>
-        <p:style>
-          <a:lnRef idx="2">
-            <a:schemeClr val="accent1"/>
-          </a:lnRef>
-          <a:fillRef idx="0">
-            <a:schemeClr val="accent1"/>
-          </a:fillRef>
-          <a:effectRef idx="1">
-            <a:schemeClr val="accent1"/>
-          </a:effectRef>
-          <a:fontRef idx="minor">
-            <a:schemeClr val="tx1"/>
-          </a:fontRef>
-        </p:style>
       </p:cxnSp>
       <p:sp>
         <p:nvSpPr>
@@ -7457,20 +7236,6 @@
           </a:ln>
           <a:effectLst/>
         </p:spPr>
-        <p:style>
-          <a:lnRef idx="1">
-            <a:schemeClr val="accent1"/>
-          </a:lnRef>
-          <a:fillRef idx="3">
-            <a:schemeClr val="accent1"/>
-          </a:fillRef>
-          <a:effectRef idx="2">
-            <a:schemeClr val="accent1"/>
-          </a:effectRef>
-          <a:fontRef idx="minor">
-            <a:schemeClr val="lt1"/>
-          </a:fontRef>
-        </p:style>
         <p:txBody>
           <a:bodyPr rtlCol="0" anchor="ctr" wrap="square" lIns="73152" rIns="73152" tIns="27432" bIns="27432"/>
           <a:lstStyle/>
@@ -7514,20 +7279,6 @@
           </a:ln>
           <a:effectLst/>
         </p:spPr>
-        <p:style>
-          <a:lnRef idx="1">
-            <a:schemeClr val="accent1"/>
-          </a:lnRef>
-          <a:fillRef idx="3">
-            <a:schemeClr val="accent1"/>
-          </a:fillRef>
-          <a:effectRef idx="2">
-            <a:schemeClr val="accent1"/>
-          </a:effectRef>
-          <a:fontRef idx="minor">
-            <a:schemeClr val="lt1"/>
-          </a:fontRef>
-        </p:style>
         <p:txBody>
           <a:bodyPr rtlCol="0" anchor="ctr" wrap="square" lIns="73152" rIns="73152" tIns="27432" bIns="27432"/>
           <a:lstStyle/>
@@ -7566,20 +7317,6 @@
             <a:tailEnd type="triangle" w="med" len="med"/>
           </a:ln>
         </p:spPr>
-        <p:style>
-          <a:lnRef idx="2">
-            <a:schemeClr val="accent1"/>
-          </a:lnRef>
-          <a:fillRef idx="0">
-            <a:schemeClr val="accent1"/>
-          </a:fillRef>
-          <a:effectRef idx="1">
-            <a:schemeClr val="accent1"/>
-          </a:effectRef>
-          <a:fontRef idx="minor">
-            <a:schemeClr val="tx1"/>
-          </a:fontRef>
-        </p:style>
       </p:cxnSp>
       <p:sp>
         <p:nvSpPr>
@@ -7607,20 +7344,6 @@
           </a:ln>
           <a:effectLst/>
         </p:spPr>
-        <p:style>
-          <a:lnRef idx="1">
-            <a:schemeClr val="accent1"/>
-          </a:lnRef>
-          <a:fillRef idx="3">
-            <a:schemeClr val="accent1"/>
-          </a:fillRef>
-          <a:effectRef idx="2">
-            <a:schemeClr val="accent1"/>
-          </a:effectRef>
-          <a:fontRef idx="minor">
-            <a:schemeClr val="lt1"/>
-          </a:fontRef>
-        </p:style>
         <p:txBody>
           <a:bodyPr rtlCol="0" anchor="ctr" wrap="square" lIns="73152" rIns="73152" tIns="27432" bIns="27432"/>
           <a:lstStyle/>
@@ -7664,20 +7387,6 @@
           </a:ln>
           <a:effectLst/>
         </p:spPr>
-        <p:style>
-          <a:lnRef idx="1">
-            <a:schemeClr val="accent1"/>
-          </a:lnRef>
-          <a:fillRef idx="3">
-            <a:schemeClr val="accent1"/>
-          </a:fillRef>
-          <a:effectRef idx="2">
-            <a:schemeClr val="accent1"/>
-          </a:effectRef>
-          <a:fontRef idx="minor">
-            <a:schemeClr val="lt1"/>
-          </a:fontRef>
-        </p:style>
         <p:txBody>
           <a:bodyPr rtlCol="0" anchor="ctr" wrap="square" lIns="73152" rIns="73152" tIns="27432" bIns="27432"/>
           <a:lstStyle/>
@@ -7716,20 +7425,6 @@
             <a:tailEnd type="triangle" w="med" len="med"/>
           </a:ln>
         </p:spPr>
-        <p:style>
-          <a:lnRef idx="2">
-            <a:schemeClr val="accent1"/>
-          </a:lnRef>
-          <a:fillRef idx="0">
-            <a:schemeClr val="accent1"/>
-          </a:fillRef>
-          <a:effectRef idx="1">
-            <a:schemeClr val="accent1"/>
-          </a:effectRef>
-          <a:fontRef idx="minor">
-            <a:schemeClr val="tx1"/>
-          </a:fontRef>
-        </p:style>
       </p:cxnSp>
       <p:sp>
         <p:nvSpPr>
@@ -7757,20 +7452,6 @@
           </a:ln>
           <a:effectLst/>
         </p:spPr>
-        <p:style>
-          <a:lnRef idx="1">
-            <a:schemeClr val="accent1"/>
-          </a:lnRef>
-          <a:fillRef idx="3">
-            <a:schemeClr val="accent1"/>
-          </a:fillRef>
-          <a:effectRef idx="2">
-            <a:schemeClr val="accent1"/>
-          </a:effectRef>
-          <a:fontRef idx="minor">
-            <a:schemeClr val="lt1"/>
-          </a:fontRef>
-        </p:style>
         <p:txBody>
           <a:bodyPr rtlCol="0" anchor="ctr" wrap="square" lIns="73152" rIns="73152" tIns="27432" bIns="27432"/>
           <a:lstStyle/>
@@ -7818,7 +7499,7 @@
                 </a:solidFill>
                 <a:latin typeface="Arial"/>
               </a:rPr>
-              <a:t>Same score, different story - spatial-frequency features for AI-generated image detection</a:t>
+              <a:t>CSE 4883 Digital Image Processing  ·  Same score, different story</a:t>
             </a:r>
           </a:p>
         </p:txBody>
@@ -7897,20 +7578,6 @@
             <a:noFill/>
           </a:ln>
         </p:spPr>
-        <p:style>
-          <a:lnRef idx="1">
-            <a:schemeClr val="accent1"/>
-          </a:lnRef>
-          <a:fillRef idx="3">
-            <a:schemeClr val="accent1"/>
-          </a:fillRef>
-          <a:effectRef idx="2">
-            <a:schemeClr val="accent1"/>
-          </a:effectRef>
-          <a:fontRef idx="minor">
-            <a:schemeClr val="lt1"/>
-          </a:fontRef>
-        </p:style>
         <p:txBody>
           <a:bodyPr rtlCol="0" anchor="ctr"/>
           <a:lstStyle/>
@@ -7928,7 +7595,7 @@
         <p:spPr>
           <a:xfrm>
             <a:off x="548640" y="1463040"/>
-            <a:ext cx="10972800" cy="1828800"/>
+            <a:ext cx="10972800" cy="1508760"/>
           </a:xfrm>
           <a:prstGeom prst="rect">
             <a:avLst/>
@@ -8017,43 +7684,8 @@
         </p:nvSpPr>
         <p:spPr>
           <a:xfrm>
-            <a:off x="548640" y="4206240"/>
-            <a:ext cx="3566160" cy="640080"/>
-          </a:xfrm>
-          <a:prstGeom prst="rect">
-            <a:avLst/>
-          </a:prstGeom>
-          <a:noFill/>
-        </p:spPr>
-        <p:txBody>
-          <a:bodyPr wrap="square" lIns="0" rIns="0" tIns="0" bIns="0">
-            <a:spAutoFit/>
-          </a:bodyPr>
-          <a:lstStyle/>
-          <a:p>
-            <a:pPr algn="l"/>
-            <a:r>
-              <a:rPr sz="3200" b="1" i="0">
-                <a:solidFill>
-                  <a:srgbClr val="FFFFFF"/>
-                </a:solidFill>
-                <a:latin typeface="Georgia"/>
-              </a:rPr>
-              <a:t>0.793</a:t>
-            </a:r>
-          </a:p>
-        </p:txBody>
-      </p:sp>
-      <p:sp>
-        <p:nvSpPr>
-          <p:cNvPr id="6" name="TextBox 5"/>
-          <p:cNvSpPr txBox="1"/>
-          <p:nvPr/>
-        </p:nvSpPr>
-        <p:spPr>
-          <a:xfrm>
-            <a:off x="548640" y="4892040"/>
-            <a:ext cx="3566160" cy="640080"/>
+            <a:off x="548640" y="4069080"/>
+            <a:ext cx="10515600" cy="914400"/>
           </a:xfrm>
           <a:prstGeom prst="rect">
             <a:avLst/>
@@ -8068,33 +7700,106 @@
           <a:p>
             <a:pPr algn="l">
               <a:lnSpc>
-                <a:spcPct val="110000"/>
+                <a:spcPct val="130000"/>
               </a:lnSpc>
             </a:pPr>
             <a:r>
-              <a:rPr sz="1300" b="0" i="0">
+              <a:rPr sz="1600" b="0">
                 <a:solidFill>
                   <a:srgbClr val="ABB7C4"/>
                 </a:solidFill>
                 <a:latin typeface="Arial"/>
               </a:rPr>
-              <a:t>best pooled AUROC</a:t>
-            </a:r>
-          </a:p>
-          <a:p>
-            <a:pPr algn="l">
-              <a:lnSpc>
-                <a:spcPct val="110000"/>
-              </a:lnSpc>
-            </a:pPr>
-            <a:r>
-              <a:rPr sz="1300" b="0" i="0">
+              <a:t>Combined features scored best pooled (</a:t>
+            </a:r>
+            <a:r>
+              <a:rPr sz="1600" b="1">
+                <a:solidFill>
+                  <a:srgbClr val="FFFFFF"/>
+                </a:solidFill>
+                <a:latin typeface="Arial"/>
+              </a:rPr>
+              <a:t>0.793</a:t>
+            </a:r>
+            <a:r>
+              <a:rPr sz="1600" b="0">
                 <a:solidFill>
                   <a:srgbClr val="ABB7C4"/>
                 </a:solidFill>
                 <a:latin typeface="Arial"/>
               </a:rPr>
-              <a:t>(combined, clean)</a:t>
+              <a:t>; </a:t>
+            </a:r>
+            <a:r>
+              <a:rPr sz="1600" b="1">
+                <a:solidFill>
+                  <a:srgbClr val="FFFFFF"/>
+                </a:solidFill>
+                <a:latin typeface="Arial"/>
+              </a:rPr>
+              <a:t>0.629</a:t>
+            </a:r>
+            <a:r>
+              <a:rPr sz="1600" b="0">
+                <a:solidFill>
+                  <a:srgbClr val="ABB7C4"/>
+                </a:solidFill>
+                <a:latin typeface="Arial"/>
+              </a:rPr>
+              <a:t> on an unseen generator under JPEG 75), yet the same pooled score hid per-generator changes of </a:t>
+            </a:r>
+            <a:r>
+              <a:rPr sz="1600" b="1">
+                <a:solidFill>
+                  <a:srgbClr val="FFFFFF"/>
+                </a:solidFill>
+                <a:latin typeface="Arial"/>
+              </a:rPr>
+              <a:t>−0.17 to +0.30</a:t>
+            </a:r>
+            <a:r>
+              <a:rPr sz="1600" b="0">
+                <a:solidFill>
+                  <a:srgbClr val="ABB7C4"/>
+                </a:solidFill>
+                <a:latin typeface="Arial"/>
+              </a:rPr>
+              <a:t>.</a:t>
+            </a:r>
+          </a:p>
+        </p:txBody>
+      </p:sp>
+      <p:sp>
+        <p:nvSpPr>
+          <p:cNvPr id="6" name="TextBox 5"/>
+          <p:cNvSpPr txBox="1"/>
+          <p:nvPr/>
+        </p:nvSpPr>
+        <p:spPr>
+          <a:xfrm>
+            <a:off x="548640" y="5669280"/>
+            <a:ext cx="10972800" cy="365760"/>
+          </a:xfrm>
+          <a:prstGeom prst="rect">
+            <a:avLst/>
+          </a:prstGeom>
+          <a:noFill/>
+        </p:spPr>
+        <p:txBody>
+          <a:bodyPr wrap="square" lIns="0" rIns="0" tIns="0" bIns="0">
+            <a:spAutoFit/>
+          </a:bodyPr>
+          <a:lstStyle/>
+          <a:p>
+            <a:pPr algn="l"/>
+            <a:r>
+              <a:rPr sz="1800" b="1" i="0">
+                <a:solidFill>
+                  <a:srgbClr val="FFFFFF"/>
+                </a:solidFill>
+                <a:latin typeface="Georgia"/>
+              </a:rPr>
+              <a:t>Thank you  ·  questions?</a:t>
             </a:r>
           </a:p>
         </p:txBody>
@@ -8102,221 +7807,6 @@
       <p:sp>
         <p:nvSpPr>
           <p:cNvPr id="7" name="TextBox 6"/>
-          <p:cNvSpPr txBox="1"/>
-          <p:nvPr/>
-        </p:nvSpPr>
-        <p:spPr>
-          <a:xfrm>
-            <a:off x="4297679" y="4206240"/>
-            <a:ext cx="3566160" cy="640080"/>
-          </a:xfrm>
-          <a:prstGeom prst="rect">
-            <a:avLst/>
-          </a:prstGeom>
-          <a:noFill/>
-        </p:spPr>
-        <p:txBody>
-          <a:bodyPr wrap="square" lIns="0" rIns="0" tIns="0" bIns="0">
-            <a:spAutoFit/>
-          </a:bodyPr>
-          <a:lstStyle/>
-          <a:p>
-            <a:pPr algn="l"/>
-            <a:r>
-              <a:rPr sz="3200" b="1" i="0">
-                <a:solidFill>
-                  <a:srgbClr val="FFFFFF"/>
-                </a:solidFill>
-                <a:latin typeface="Georgia"/>
-              </a:rPr>
-              <a:t>0.629</a:t>
-            </a:r>
-          </a:p>
-        </p:txBody>
-      </p:sp>
-      <p:sp>
-        <p:nvSpPr>
-          <p:cNvPr id="8" name="TextBox 7"/>
-          <p:cNvSpPr txBox="1"/>
-          <p:nvPr/>
-        </p:nvSpPr>
-        <p:spPr>
-          <a:xfrm>
-            <a:off x="4297679" y="4892040"/>
-            <a:ext cx="3566160" cy="640080"/>
-          </a:xfrm>
-          <a:prstGeom prst="rect">
-            <a:avLst/>
-          </a:prstGeom>
-          <a:noFill/>
-        </p:spPr>
-        <p:txBody>
-          <a:bodyPr wrap="square" lIns="0" rIns="0" tIns="0" bIns="0">
-            <a:spAutoFit/>
-          </a:bodyPr>
-          <a:lstStyle/>
-          <a:p>
-            <a:pPr algn="l">
-              <a:lnSpc>
-                <a:spcPct val="110000"/>
-              </a:lnSpc>
-            </a:pPr>
-            <a:r>
-              <a:rPr sz="1300" b="0" i="0">
-                <a:solidFill>
-                  <a:srgbClr val="ABB7C4"/>
-                </a:solidFill>
-                <a:latin typeface="Arial"/>
-              </a:rPr>
-              <a:t>unseen generator</a:t>
-            </a:r>
-          </a:p>
-          <a:p>
-            <a:pPr algn="l">
-              <a:lnSpc>
-                <a:spcPct val="110000"/>
-              </a:lnSpc>
-            </a:pPr>
-            <a:r>
-              <a:rPr sz="1300" b="0" i="0">
-                <a:solidFill>
-                  <a:srgbClr val="ABB7C4"/>
-                </a:solidFill>
-                <a:latin typeface="Arial"/>
-              </a:rPr>
-              <a:t>under JPEG 75</a:t>
-            </a:r>
-          </a:p>
-        </p:txBody>
-      </p:sp>
-      <p:sp>
-        <p:nvSpPr>
-          <p:cNvPr id="9" name="TextBox 8"/>
-          <p:cNvSpPr txBox="1"/>
-          <p:nvPr/>
-        </p:nvSpPr>
-        <p:spPr>
-          <a:xfrm>
-            <a:off x="8046718" y="4206240"/>
-            <a:ext cx="3566160" cy="640080"/>
-          </a:xfrm>
-          <a:prstGeom prst="rect">
-            <a:avLst/>
-          </a:prstGeom>
-          <a:noFill/>
-        </p:spPr>
-        <p:txBody>
-          <a:bodyPr wrap="square" lIns="0" rIns="0" tIns="0" bIns="0">
-            <a:spAutoFit/>
-          </a:bodyPr>
-          <a:lstStyle/>
-          <a:p>
-            <a:pPr algn="l"/>
-            <a:r>
-              <a:rPr sz="3200" b="1" i="0">
-                <a:solidFill>
-                  <a:srgbClr val="FFFFFF"/>
-                </a:solidFill>
-                <a:latin typeface="Georgia"/>
-              </a:rPr>
-              <a:t>-0.17 to +0.30</a:t>
-            </a:r>
-          </a:p>
-        </p:txBody>
-      </p:sp>
-      <p:sp>
-        <p:nvSpPr>
-          <p:cNvPr id="10" name="TextBox 9"/>
-          <p:cNvSpPr txBox="1"/>
-          <p:nvPr/>
-        </p:nvSpPr>
-        <p:spPr>
-          <a:xfrm>
-            <a:off x="8046718" y="4892040"/>
-            <a:ext cx="3566160" cy="640080"/>
-          </a:xfrm>
-          <a:prstGeom prst="rect">
-            <a:avLst/>
-          </a:prstGeom>
-          <a:noFill/>
-        </p:spPr>
-        <p:txBody>
-          <a:bodyPr wrap="square" lIns="0" rIns="0" tIns="0" bIns="0">
-            <a:spAutoFit/>
-          </a:bodyPr>
-          <a:lstStyle/>
-          <a:p>
-            <a:pPr algn="l">
-              <a:lnSpc>
-                <a:spcPct val="110000"/>
-              </a:lnSpc>
-            </a:pPr>
-            <a:r>
-              <a:rPr sz="1300" b="0" i="0">
-                <a:solidFill>
-                  <a:srgbClr val="ABB7C4"/>
-                </a:solidFill>
-                <a:latin typeface="Arial"/>
-              </a:rPr>
-              <a:t>per-generator change,</a:t>
-            </a:r>
-          </a:p>
-          <a:p>
-            <a:pPr algn="l">
-              <a:lnSpc>
-                <a:spcPct val="110000"/>
-              </a:lnSpc>
-            </a:pPr>
-            <a:r>
-              <a:rPr sz="1300" b="0" i="0">
-                <a:solidFill>
-                  <a:srgbClr val="ABB7C4"/>
-                </a:solidFill>
-                <a:latin typeface="Arial"/>
-              </a:rPr>
-              <a:t>same pooled score</a:t>
-            </a:r>
-          </a:p>
-        </p:txBody>
-      </p:sp>
-      <p:sp>
-        <p:nvSpPr>
-          <p:cNvPr id="11" name="TextBox 10"/>
-          <p:cNvSpPr txBox="1"/>
-          <p:nvPr/>
-        </p:nvSpPr>
-        <p:spPr>
-          <a:xfrm>
-            <a:off x="548640" y="5897880"/>
-            <a:ext cx="10972800" cy="365760"/>
-          </a:xfrm>
-          <a:prstGeom prst="rect">
-            <a:avLst/>
-          </a:prstGeom>
-          <a:noFill/>
-        </p:spPr>
-        <p:txBody>
-          <a:bodyPr wrap="square" lIns="0" rIns="0" tIns="0" bIns="0">
-            <a:spAutoFit/>
-          </a:bodyPr>
-          <a:lstStyle/>
-          <a:p>
-            <a:pPr algn="l"/>
-            <a:r>
-              <a:rPr sz="1600" b="1" i="0">
-                <a:solidFill>
-                  <a:srgbClr val="ABB7C4"/>
-                </a:solidFill>
-                <a:latin typeface="Arial"/>
-              </a:rPr>
-              <a:t>Thank you - questions?</a:t>
-            </a:r>
-          </a:p>
-        </p:txBody>
-      </p:sp>
-      <p:sp>
-        <p:nvSpPr>
-          <p:cNvPr id="12" name="TextBox 11"/>
           <p:cNvSpPr txBox="1"/>
           <p:nvPr/>
         </p:nvSpPr>
@@ -8344,14 +7834,14 @@
                 </a:solidFill>
                 <a:latin typeface="Arial"/>
               </a:rPr>
-              <a:t>Same score, different story - spatial-frequency features for AI-generated image detection</a:t>
-            </a:r>
-          </a:p>
-        </p:txBody>
-      </p:sp>
-      <p:sp>
-        <p:nvSpPr>
-          <p:cNvPr id="13" name="TextBox 12"/>
+              <a:t>CSE 4883 Digital Image Processing  ·  Same score, different story</a:t>
+            </a:r>
+          </a:p>
+        </p:txBody>
+      </p:sp>
+      <p:sp>
+        <p:nvSpPr>
+          <p:cNvPr id="8" name="TextBox 7"/>
           <p:cNvSpPr txBox="1"/>
           <p:nvPr/>
         </p:nvSpPr>
@@ -8458,20 +7948,6 @@
             <a:noFill/>
           </a:ln>
         </p:spPr>
-        <p:style>
-          <a:lnRef idx="1">
-            <a:schemeClr val="accent1"/>
-          </a:lnRef>
-          <a:fillRef idx="3">
-            <a:schemeClr val="accent1"/>
-          </a:fillRef>
-          <a:effectRef idx="2">
-            <a:schemeClr val="accent1"/>
-          </a:effectRef>
-          <a:fontRef idx="minor">
-            <a:schemeClr val="lt1"/>
-          </a:fontRef>
-        </p:style>
         <p:txBody>
           <a:bodyPr rtlCol="0" anchor="ctr"/>
           <a:lstStyle/>
@@ -8506,7 +7982,7 @@
             <a:r>
               <a:rPr sz="1050" b="0" i="0">
                 <a:solidFill>
-                  <a:srgbClr val="A9B4C0"/>
+                  <a:srgbClr val="5D6D7E"/>
                 </a:solidFill>
                 <a:latin typeface="Arial"/>
               </a:rPr>
@@ -8541,7 +8017,7 @@
             <a:r>
               <a:rPr sz="1050" b="0" i="0">
                 <a:solidFill>
-                  <a:srgbClr val="A9B4C0"/>
+                  <a:srgbClr val="5D6D7E"/>
                 </a:solidFill>
                 <a:latin typeface="Arial"/>
               </a:rPr>
@@ -8576,7 +8052,7 @@
             <a:r>
               <a:rPr sz="1050" b="0" i="0">
                 <a:solidFill>
-                  <a:srgbClr val="A9B4C0"/>
+                  <a:srgbClr val="5D6D7E"/>
                 </a:solidFill>
                 <a:latin typeface="Arial"/>
               </a:rPr>
@@ -8611,7 +8087,7 @@
             <a:r>
               <a:rPr sz="1050" b="0" i="0">
                 <a:solidFill>
-                  <a:srgbClr val="A9B4C0"/>
+                  <a:srgbClr val="5D6D7E"/>
                 </a:solidFill>
                 <a:latin typeface="Arial"/>
               </a:rPr>
@@ -8646,7 +8122,7 @@
             <a:r>
               <a:rPr sz="1050" b="0" i="0">
                 <a:solidFill>
-                  <a:srgbClr val="A9B4C0"/>
+                  <a:srgbClr val="5D6D7E"/>
                 </a:solidFill>
                 <a:latin typeface="Arial"/>
               </a:rPr>
@@ -8681,7 +8157,7 @@
             <a:r>
               <a:rPr sz="1050" b="0" i="0">
                 <a:solidFill>
-                  <a:srgbClr val="A9B4C0"/>
+                  <a:srgbClr val="5D6D7E"/>
                 </a:solidFill>
                 <a:latin typeface="Arial"/>
               </a:rPr>
@@ -8711,20 +8187,6 @@
             <a:noFill/>
           </a:ln>
         </p:spPr>
-        <p:style>
-          <a:lnRef idx="1">
-            <a:schemeClr val="accent1"/>
-          </a:lnRef>
-          <a:fillRef idx="3">
-            <a:schemeClr val="accent1"/>
-          </a:fillRef>
-          <a:effectRef idx="2">
-            <a:schemeClr val="accent1"/>
-          </a:effectRef>
-          <a:fontRef idx="minor">
-            <a:schemeClr val="lt1"/>
-          </a:fontRef>
-        </p:style>
         <p:txBody>
           <a:bodyPr rtlCol="0" anchor="ctr"/>
           <a:lstStyle/>
@@ -8742,7 +8204,7 @@
         <p:spPr>
           <a:xfrm>
             <a:off x="548640" y="713232"/>
-            <a:ext cx="9509760" cy="548640"/>
+            <a:ext cx="9418320" cy="548640"/>
           </a:xfrm>
           <a:prstGeom prst="rect">
             <a:avLst/>
@@ -8776,8 +8238,8 @@
         </p:nvSpPr>
         <p:spPr>
           <a:xfrm>
-            <a:off x="9997135" y="822960"/>
-            <a:ext cx="1645920" cy="274320"/>
+            <a:off x="10271455" y="822960"/>
+            <a:ext cx="1371600" cy="274320"/>
           </a:xfrm>
           <a:prstGeom prst="rect">
             <a:avLst/>
@@ -8819,8 +8281,8 @@
         </p:blipFill>
         <p:spPr>
           <a:xfrm>
-            <a:off x="548640" y="1965670"/>
-            <a:ext cx="7589520" cy="3127827"/>
+            <a:off x="1097280" y="1391827"/>
+            <a:ext cx="9997135" cy="4120065"/>
           </a:xfrm>
           <a:prstGeom prst="rect">
             <a:avLst/>
@@ -8840,8 +8302,8 @@
         </p:nvSpPr>
         <p:spPr>
           <a:xfrm>
-            <a:off x="548640" y="5203225"/>
-            <a:ext cx="7589520" cy="621792"/>
+            <a:off x="548640" y="5669280"/>
+            <a:ext cx="11094415" cy="731520"/>
           </a:xfrm>
           <a:prstGeom prst="rect">
             <a:avLst/>
@@ -8856,17 +8318,44 @@
           <a:p>
             <a:pPr algn="ctr">
               <a:lnSpc>
-                <a:spcPct val="105000"/>
+                <a:spcPct val="120000"/>
               </a:lnSpc>
             </a:pPr>
             <a:r>
-              <a:rPr sz="1200" b="0" i="0">
-                <a:solidFill>
-                  <a:srgbClr val="5D6D7E"/>
-                </a:solidFill>
-                <a:latin typeface="Arial"/>
-              </a:rPr>
-              <a:t>One GenImage test image per class, drawn at its true native size.</a:t>
+              <a:rPr sz="1700" b="0">
+                <a:solidFill>
+                  <a:srgbClr val="1C2833"/>
+                </a:solidFill>
+                <a:latin typeface="Arial"/>
+              </a:rPr>
+              <a:t>File format and size alone separate the classes (AUROC </a:t>
+            </a:r>
+            <a:r>
+              <a:rPr sz="1700" b="1">
+                <a:solidFill>
+                  <a:srgbClr val="B2182B"/>
+                </a:solidFill>
+                <a:latin typeface="Arial"/>
+              </a:rPr>
+              <a:t>1.000</a:t>
+            </a:r>
+            <a:r>
+              <a:rPr sz="1700" b="0">
+                <a:solidFill>
+                  <a:srgbClr val="1C2833"/>
+                </a:solidFill>
+                <a:latin typeface="Arial"/>
+              </a:rPr>
+              <a:t>). A fair pipeline gives every image 256 × 256 px, but </a:t>
+            </a:r>
+            <a:r>
+              <a:rPr sz="1700" b="1">
+                <a:solidFill>
+                  <a:srgbClr val="B2182B"/>
+                </a:solidFill>
+                <a:latin typeface="Arial"/>
+              </a:rPr>
+              <a:t>each class is resized by a different factor.</a:t>
             </a:r>
           </a:p>
         </p:txBody>
@@ -8874,236 +8363,6 @@
       <p:sp>
         <p:nvSpPr>
           <p:cNvPr id="15" name="TextBox 14"/>
-          <p:cNvSpPr txBox="1"/>
-          <p:nvPr/>
-        </p:nvSpPr>
-        <p:spPr>
-          <a:xfrm>
-            <a:off x="8549640" y="1600200"/>
-            <a:ext cx="3108960" cy="630620"/>
-          </a:xfrm>
-          <a:prstGeom prst="rect">
-            <a:avLst/>
-          </a:prstGeom>
-          <a:noFill/>
-        </p:spPr>
-        <p:txBody>
-          <a:bodyPr wrap="square" lIns="0" rIns="0" tIns="0" bIns="0">
-            <a:spAutoFit/>
-          </a:bodyPr>
-          <a:lstStyle/>
-          <a:p>
-            <a:pPr algn="l"/>
-            <a:r>
-              <a:rPr sz="4000" b="1" i="0">
-                <a:solidFill>
-                  <a:srgbClr val="B2182B"/>
-                </a:solidFill>
-                <a:latin typeface="Georgia"/>
-              </a:rPr>
-              <a:t>1.000</a:t>
-            </a:r>
-          </a:p>
-        </p:txBody>
-      </p:sp>
-      <p:sp>
-        <p:nvSpPr>
-          <p:cNvPr id="16" name="TextBox 15"/>
-          <p:cNvSpPr txBox="1"/>
-          <p:nvPr/>
-        </p:nvSpPr>
-        <p:spPr>
-          <a:xfrm>
-            <a:off x="8549640" y="2276540"/>
-            <a:ext cx="3108960" cy="548640"/>
-          </a:xfrm>
-          <a:prstGeom prst="rect">
-            <a:avLst/>
-          </a:prstGeom>
-          <a:noFill/>
-        </p:spPr>
-        <p:txBody>
-          <a:bodyPr wrap="square" lIns="0" rIns="0" tIns="0" bIns="0">
-            <a:spAutoFit/>
-          </a:bodyPr>
-          <a:lstStyle/>
-          <a:p>
-            <a:pPr algn="l">
-              <a:lnSpc>
-                <a:spcPct val="105000"/>
-              </a:lnSpc>
-            </a:pPr>
-            <a:r>
-              <a:rPr sz="1250" b="0" i="0">
-                <a:solidFill>
-                  <a:srgbClr val="5D6D7E"/>
-                </a:solidFill>
-                <a:latin typeface="Arial"/>
-              </a:rPr>
-              <a:t>AUROC from file format + size alone -</a:t>
-            </a:r>
-          </a:p>
-          <a:p>
-            <a:pPr algn="l">
-              <a:lnSpc>
-                <a:spcPct val="105000"/>
-              </a:lnSpc>
-            </a:pPr>
-            <a:r>
-              <a:rPr sz="1250" b="0" i="0">
-                <a:solidFill>
-                  <a:srgbClr val="5D6D7E"/>
-                </a:solidFill>
-                <a:latin typeface="Arial"/>
-              </a:rPr>
-              <a:t>no pixels needed</a:t>
-            </a:r>
-          </a:p>
-        </p:txBody>
-      </p:sp>
-      <p:sp>
-        <p:nvSpPr>
-          <p:cNvPr id="17" name="TextBox 16"/>
-          <p:cNvSpPr txBox="1"/>
-          <p:nvPr/>
-        </p:nvSpPr>
-        <p:spPr>
-          <a:xfrm>
-            <a:off x="8549640" y="3246120"/>
-            <a:ext cx="3108960" cy="320040"/>
-          </a:xfrm>
-          <a:prstGeom prst="rect">
-            <a:avLst/>
-          </a:prstGeom>
-          <a:noFill/>
-        </p:spPr>
-        <p:txBody>
-          <a:bodyPr wrap="square" lIns="0" rIns="0" tIns="0" bIns="0">
-            <a:spAutoFit/>
-          </a:bodyPr>
-          <a:lstStyle/>
-          <a:p>
-            <a:pPr algn="l"/>
-            <a:r>
-              <a:rPr sz="1400" b="1" i="0">
-                <a:solidFill>
-                  <a:srgbClr val="1F3A5F"/>
-                </a:solidFill>
-                <a:latin typeface="Arial"/>
-              </a:rPr>
-              <a:t>So a fair pipeline must</a:t>
-            </a:r>
-          </a:p>
-        </p:txBody>
-      </p:sp>
-      <p:sp>
-        <p:nvSpPr>
-          <p:cNvPr id="18" name="TextBox 17"/>
-          <p:cNvSpPr txBox="1"/>
-          <p:nvPr/>
-        </p:nvSpPr>
-        <p:spPr>
-          <a:xfrm>
-            <a:off x="8549640" y="3639312"/>
-            <a:ext cx="3108960" cy="365760"/>
-          </a:xfrm>
-          <a:prstGeom prst="rect">
-            <a:avLst/>
-          </a:prstGeom>
-          <a:noFill/>
-        </p:spPr>
-        <p:txBody>
-          <a:bodyPr wrap="square" lIns="0" rIns="0" tIns="0" bIns="0">
-            <a:spAutoFit/>
-          </a:bodyPr>
-          <a:lstStyle/>
-          <a:p>
-            <a:pPr algn="l"/>
-            <a:r>
-              <a:rPr sz="1400" b="0" i="0">
-                <a:solidFill>
-                  <a:srgbClr val="1C2833"/>
-                </a:solidFill>
-                <a:latin typeface="Arial"/>
-              </a:rPr>
-              <a:t>give both classes one size (256 px)</a:t>
-            </a:r>
-          </a:p>
-        </p:txBody>
-      </p:sp>
-      <p:sp>
-        <p:nvSpPr>
-          <p:cNvPr id="19" name="TextBox 18"/>
-          <p:cNvSpPr txBox="1"/>
-          <p:nvPr/>
-        </p:nvSpPr>
-        <p:spPr>
-          <a:xfrm>
-            <a:off x="8549640" y="4050791"/>
-            <a:ext cx="3108960" cy="365760"/>
-          </a:xfrm>
-          <a:prstGeom prst="rect">
-            <a:avLst/>
-          </a:prstGeom>
-          <a:noFill/>
-        </p:spPr>
-        <p:txBody>
-          <a:bodyPr wrap="square" lIns="0" rIns="0" tIns="0" bIns="0">
-            <a:spAutoFit/>
-          </a:bodyPr>
-          <a:lstStyle/>
-          <a:p>
-            <a:pPr algn="l"/>
-            <a:r>
-              <a:rPr sz="1400" b="0" i="0">
-                <a:solidFill>
-                  <a:srgbClr val="1C2833"/>
-                </a:solidFill>
-                <a:latin typeface="Arial"/>
-              </a:rPr>
-              <a:t>and one format (PNG)</a:t>
-            </a:r>
-          </a:p>
-        </p:txBody>
-      </p:sp>
-      <p:sp>
-        <p:nvSpPr>
-          <p:cNvPr id="20" name="TextBox 19"/>
-          <p:cNvSpPr txBox="1"/>
-          <p:nvPr/>
-        </p:nvSpPr>
-        <p:spPr>
-          <a:xfrm>
-            <a:off x="8549640" y="4462272"/>
-            <a:ext cx="3108960" cy="365760"/>
-          </a:xfrm>
-          <a:prstGeom prst="rect">
-            <a:avLst/>
-          </a:prstGeom>
-          <a:noFill/>
-        </p:spPr>
-        <p:txBody>
-          <a:bodyPr wrap="square" lIns="0" rIns="0" tIns="0" bIns="0">
-            <a:spAutoFit/>
-          </a:bodyPr>
-          <a:lstStyle/>
-          <a:p>
-            <a:pPr algn="l"/>
-            <a:r>
-              <a:rPr sz="1400" b="1" i="0">
-                <a:solidFill>
-                  <a:srgbClr val="B2182B"/>
-                </a:solidFill>
-                <a:latin typeface="Arial"/>
-              </a:rPr>
-              <a:t>→ but each class is resized by a different factor</a:t>
-            </a:r>
-          </a:p>
-        </p:txBody>
-      </p:sp>
-      <p:sp>
-        <p:nvSpPr>
-          <p:cNvPr id="21" name="TextBox 20"/>
           <p:cNvSpPr txBox="1"/>
           <p:nvPr/>
         </p:nvSpPr>
@@ -9131,14 +8390,14 @@
                 </a:solidFill>
                 <a:latin typeface="Arial"/>
               </a:rPr>
-              <a:t>Same score, different story - spatial-frequency features for AI-generated image detection</a:t>
-            </a:r>
-          </a:p>
-        </p:txBody>
-      </p:sp>
-      <p:sp>
-        <p:nvSpPr>
-          <p:cNvPr id="22" name="TextBox 21"/>
+              <a:t>CSE 4883 Digital Image Processing  ·  Same score, different story</a:t>
+            </a:r>
+          </a:p>
+        </p:txBody>
+      </p:sp>
+      <p:sp>
+        <p:nvSpPr>
+          <p:cNvPr id="16" name="TextBox 15"/>
           <p:cNvSpPr txBox="1"/>
           <p:nvPr/>
         </p:nvSpPr>
@@ -9245,20 +8504,6 @@
             <a:noFill/>
           </a:ln>
         </p:spPr>
-        <p:style>
-          <a:lnRef idx="1">
-            <a:schemeClr val="accent1"/>
-          </a:lnRef>
-          <a:fillRef idx="3">
-            <a:schemeClr val="accent1"/>
-          </a:fillRef>
-          <a:effectRef idx="2">
-            <a:schemeClr val="accent1"/>
-          </a:effectRef>
-          <a:fontRef idx="minor">
-            <a:schemeClr val="lt1"/>
-          </a:fontRef>
-        </p:style>
         <p:txBody>
           <a:bodyPr rtlCol="0" anchor="ctr"/>
           <a:lstStyle/>
@@ -9293,7 +8538,7 @@
             <a:r>
               <a:rPr sz="1050" b="0" i="0">
                 <a:solidFill>
-                  <a:srgbClr val="A9B4C0"/>
+                  <a:srgbClr val="5D6D7E"/>
                 </a:solidFill>
                 <a:latin typeface="Arial"/>
               </a:rPr>
@@ -9328,7 +8573,7 @@
             <a:r>
               <a:rPr sz="1050" b="0" i="0">
                 <a:solidFill>
-                  <a:srgbClr val="A9B4C0"/>
+                  <a:srgbClr val="5D6D7E"/>
                 </a:solidFill>
                 <a:latin typeface="Arial"/>
               </a:rPr>
@@ -9363,7 +8608,7 @@
             <a:r>
               <a:rPr sz="1050" b="0" i="0">
                 <a:solidFill>
-                  <a:srgbClr val="A9B4C0"/>
+                  <a:srgbClr val="5D6D7E"/>
                 </a:solidFill>
                 <a:latin typeface="Arial"/>
               </a:rPr>
@@ -9398,7 +8643,7 @@
             <a:r>
               <a:rPr sz="1050" b="0" i="0">
                 <a:solidFill>
-                  <a:srgbClr val="A9B4C0"/>
+                  <a:srgbClr val="5D6D7E"/>
                 </a:solidFill>
                 <a:latin typeface="Arial"/>
               </a:rPr>
@@ -9433,7 +8678,7 @@
             <a:r>
               <a:rPr sz="1050" b="0" i="0">
                 <a:solidFill>
-                  <a:srgbClr val="A9B4C0"/>
+                  <a:srgbClr val="5D6D7E"/>
                 </a:solidFill>
                 <a:latin typeface="Arial"/>
               </a:rPr>
@@ -9468,7 +8713,7 @@
             <a:r>
               <a:rPr sz="1050" b="0" i="0">
                 <a:solidFill>
-                  <a:srgbClr val="A9B4C0"/>
+                  <a:srgbClr val="5D6D7E"/>
                 </a:solidFill>
                 <a:latin typeface="Arial"/>
               </a:rPr>
@@ -9498,20 +8743,6 @@
             <a:noFill/>
           </a:ln>
         </p:spPr>
-        <p:style>
-          <a:lnRef idx="1">
-            <a:schemeClr val="accent1"/>
-          </a:lnRef>
-          <a:fillRef idx="3">
-            <a:schemeClr val="accent1"/>
-          </a:fillRef>
-          <a:effectRef idx="2">
-            <a:schemeClr val="accent1"/>
-          </a:effectRef>
-          <a:fontRef idx="minor">
-            <a:schemeClr val="lt1"/>
-          </a:fontRef>
-        </p:style>
         <p:txBody>
           <a:bodyPr rtlCol="0" anchor="ctr"/>
           <a:lstStyle/>
@@ -9529,7 +8760,7 @@
         <p:spPr>
           <a:xfrm>
             <a:off x="548640" y="713232"/>
-            <a:ext cx="9509760" cy="548640"/>
+            <a:ext cx="9418320" cy="548640"/>
           </a:xfrm>
           <a:prstGeom prst="rect">
             <a:avLst/>
@@ -9563,8 +8794,8 @@
         </p:nvSpPr>
         <p:spPr>
           <a:xfrm>
-            <a:off x="9997135" y="822960"/>
-            <a:ext cx="1645920" cy="274320"/>
+            <a:off x="10271455" y="822960"/>
+            <a:ext cx="1371600" cy="274320"/>
           </a:xfrm>
           <a:prstGeom prst="rect">
             <a:avLst/>
@@ -9616,20 +8847,6 @@
           </a:ln>
           <a:effectLst/>
         </p:spPr>
-        <p:style>
-          <a:lnRef idx="1">
-            <a:schemeClr val="accent1"/>
-          </a:lnRef>
-          <a:fillRef idx="3">
-            <a:schemeClr val="accent1"/>
-          </a:fillRef>
-          <a:effectRef idx="2">
-            <a:schemeClr val="accent1"/>
-          </a:effectRef>
-          <a:fontRef idx="minor">
-            <a:schemeClr val="lt1"/>
-          </a:fontRef>
-        </p:style>
         <p:txBody>
           <a:bodyPr rtlCol="0" anchor="ctr" wrap="square" lIns="73152" rIns="73152" tIns="27432" bIns="27432"/>
           <a:lstStyle/>
@@ -9654,7 +8871,7 @@
                 </a:solidFill>
                 <a:latin typeface="Arial"/>
               </a:rPr>
-              <a:t>same processing for both classes - strict split by image group</a:t>
+              <a:t>same processing for both classes  ·  strict split by image group</a:t>
             </a:r>
           </a:p>
         </p:txBody>
@@ -9680,20 +8897,6 @@
             <a:tailEnd type="triangle" w="med" len="med"/>
           </a:ln>
         </p:spPr>
-        <p:style>
-          <a:lnRef idx="2">
-            <a:schemeClr val="accent1"/>
-          </a:lnRef>
-          <a:fillRef idx="0">
-            <a:schemeClr val="accent1"/>
-          </a:fillRef>
-          <a:effectRef idx="1">
-            <a:schemeClr val="accent1"/>
-          </a:effectRef>
-          <a:fontRef idx="minor">
-            <a:schemeClr val="tx1"/>
-          </a:fontRef>
-        </p:style>
       </p:cxnSp>
       <p:sp>
         <p:nvSpPr>
@@ -9721,20 +8924,6 @@
           </a:ln>
           <a:effectLst/>
         </p:spPr>
-        <p:style>
-          <a:lnRef idx="1">
-            <a:schemeClr val="accent1"/>
-          </a:lnRef>
-          <a:fillRef idx="3">
-            <a:schemeClr val="accent1"/>
-          </a:fillRef>
-          <a:effectRef idx="2">
-            <a:schemeClr val="accent1"/>
-          </a:effectRef>
-          <a:fontRef idx="minor">
-            <a:schemeClr val="lt1"/>
-          </a:fontRef>
-        </p:style>
         <p:txBody>
           <a:bodyPr rtlCol="0" anchor="ctr" wrap="square" lIns="73152" rIns="73152" tIns="27432" bIns="27432"/>
           <a:lstStyle/>
@@ -9743,7 +8932,7 @@
             <a:r>
               <a:rPr sz="1700" b="1">
                 <a:solidFill>
-                  <a:srgbClr val="2A78D6"/>
+                  <a:srgbClr val="1F63B8"/>
                 </a:solidFill>
                 <a:latin typeface="Arial"/>
               </a:rPr>
@@ -9785,20 +8974,6 @@
             <a:tailEnd type="triangle" w="med" len="med"/>
           </a:ln>
         </p:spPr>
-        <p:style>
-          <a:lnRef idx="2">
-            <a:schemeClr val="accent1"/>
-          </a:lnRef>
-          <a:fillRef idx="0">
-            <a:schemeClr val="accent1"/>
-          </a:fillRef>
-          <a:effectRef idx="1">
-            <a:schemeClr val="accent1"/>
-          </a:effectRef>
-          <a:fontRef idx="minor">
-            <a:schemeClr val="tx1"/>
-          </a:fontRef>
-        </p:style>
       </p:cxnSp>
       <p:cxnSp>
         <p:nvCxnSpPr>
@@ -9821,20 +8996,6 @@
             <a:tailEnd type="triangle" w="med" len="med"/>
           </a:ln>
         </p:spPr>
-        <p:style>
-          <a:lnRef idx="2">
-            <a:schemeClr val="accent1"/>
-          </a:lnRef>
-          <a:fillRef idx="0">
-            <a:schemeClr val="accent1"/>
-          </a:fillRef>
-          <a:effectRef idx="1">
-            <a:schemeClr val="accent1"/>
-          </a:effectRef>
-          <a:fontRef idx="minor">
-            <a:schemeClr val="tx1"/>
-          </a:fontRef>
-        </p:style>
       </p:cxnSp>
       <p:sp>
         <p:nvSpPr>
@@ -9862,20 +9023,6 @@
           </a:ln>
           <a:effectLst/>
         </p:spPr>
-        <p:style>
-          <a:lnRef idx="1">
-            <a:schemeClr val="accent1"/>
-          </a:lnRef>
-          <a:fillRef idx="3">
-            <a:schemeClr val="accent1"/>
-          </a:fillRef>
-          <a:effectRef idx="2">
-            <a:schemeClr val="accent1"/>
-          </a:effectRef>
-          <a:fontRef idx="minor">
-            <a:schemeClr val="lt1"/>
-          </a:fontRef>
-        </p:style>
         <p:txBody>
           <a:bodyPr rtlCol="0" anchor="ctr" wrap="square" lIns="73152" rIns="73152" tIns="27432" bIns="27432"/>
           <a:lstStyle/>
@@ -9884,7 +9031,7 @@
             <a:r>
               <a:rPr sz="1700" b="1">
                 <a:solidFill>
-                  <a:srgbClr val="EB6834"/>
+                  <a:srgbClr val="B54819"/>
                 </a:solidFill>
                 <a:latin typeface="Arial"/>
               </a:rPr>
@@ -9926,20 +9073,6 @@
             <a:tailEnd type="triangle" w="med" len="med"/>
           </a:ln>
         </p:spPr>
-        <p:style>
-          <a:lnRef idx="2">
-            <a:schemeClr val="accent1"/>
-          </a:lnRef>
-          <a:fillRef idx="0">
-            <a:schemeClr val="accent1"/>
-          </a:fillRef>
-          <a:effectRef idx="1">
-            <a:schemeClr val="accent1"/>
-          </a:effectRef>
-          <a:fontRef idx="minor">
-            <a:schemeClr val="tx1"/>
-          </a:fontRef>
-        </p:style>
       </p:cxnSp>
       <p:cxnSp>
         <p:nvCxnSpPr>
@@ -9962,20 +9095,6 @@
             <a:tailEnd type="triangle" w="med" len="med"/>
           </a:ln>
         </p:spPr>
-        <p:style>
-          <a:lnRef idx="2">
-            <a:schemeClr val="accent1"/>
-          </a:lnRef>
-          <a:fillRef idx="0">
-            <a:schemeClr val="accent1"/>
-          </a:fillRef>
-          <a:effectRef idx="1">
-            <a:schemeClr val="accent1"/>
-          </a:effectRef>
-          <a:fontRef idx="minor">
-            <a:schemeClr val="tx1"/>
-          </a:fontRef>
-        </p:style>
       </p:cxnSp>
       <p:sp>
         <p:nvSpPr>
@@ -10003,20 +9122,6 @@
           </a:ln>
           <a:effectLst/>
         </p:spPr>
-        <p:style>
-          <a:lnRef idx="1">
-            <a:schemeClr val="accent1"/>
-          </a:lnRef>
-          <a:fillRef idx="3">
-            <a:schemeClr val="accent1"/>
-          </a:fillRef>
-          <a:effectRef idx="2">
-            <a:schemeClr val="accent1"/>
-          </a:effectRef>
-          <a:fontRef idx="minor">
-            <a:schemeClr val="lt1"/>
-          </a:fontRef>
-        </p:style>
         <p:txBody>
           <a:bodyPr rtlCol="0" anchor="ctr" wrap="square" lIns="73152" rIns="73152" tIns="27432" bIns="27432"/>
           <a:lstStyle/>
@@ -10025,7 +9130,7 @@
             <a:r>
               <a:rPr sz="1700" b="1">
                 <a:solidFill>
-                  <a:srgbClr val="1BAF7A"/>
+                  <a:srgbClr val="0E7A53"/>
                 </a:solidFill>
                 <a:latin typeface="Arial"/>
               </a:rPr>
@@ -10067,20 +9172,6 @@
             <a:tailEnd type="triangle" w="med" len="med"/>
           </a:ln>
         </p:spPr>
-        <p:style>
-          <a:lnRef idx="2">
-            <a:schemeClr val="accent1"/>
-          </a:lnRef>
-          <a:fillRef idx="0">
-            <a:schemeClr val="accent1"/>
-          </a:fillRef>
-          <a:effectRef idx="1">
-            <a:schemeClr val="accent1"/>
-          </a:effectRef>
-          <a:fontRef idx="minor">
-            <a:schemeClr val="tx1"/>
-          </a:fontRef>
-        </p:style>
       </p:cxnSp>
       <p:sp>
         <p:nvSpPr>
@@ -10108,20 +9199,6 @@
           </a:ln>
           <a:effectLst/>
         </p:spPr>
-        <p:style>
-          <a:lnRef idx="1">
-            <a:schemeClr val="accent1"/>
-          </a:lnRef>
-          <a:fillRef idx="3">
-            <a:schemeClr val="accent1"/>
-          </a:fillRef>
-          <a:effectRef idx="2">
-            <a:schemeClr val="accent1"/>
-          </a:effectRef>
-          <a:fontRef idx="minor">
-            <a:schemeClr val="lt1"/>
-          </a:fontRef>
-        </p:style>
         <p:txBody>
           <a:bodyPr rtlCol="0" anchor="ctr" wrap="square" lIns="73152" rIns="73152" tIns="27432" bIns="27432"/>
           <a:lstStyle/>
@@ -10160,20 +9237,6 @@
             <a:tailEnd type="triangle" w="med" len="med"/>
           </a:ln>
         </p:spPr>
-        <p:style>
-          <a:lnRef idx="2">
-            <a:schemeClr val="accent1"/>
-          </a:lnRef>
-          <a:fillRef idx="0">
-            <a:schemeClr val="accent1"/>
-          </a:fillRef>
-          <a:effectRef idx="1">
-            <a:schemeClr val="accent1"/>
-          </a:effectRef>
-          <a:fontRef idx="minor">
-            <a:schemeClr val="tx1"/>
-          </a:fontRef>
-        </p:style>
       </p:cxnSp>
       <p:cxnSp>
         <p:nvCxnSpPr>
@@ -10196,20 +9259,6 @@
             <a:tailEnd type="triangle" w="med" len="med"/>
           </a:ln>
         </p:spPr>
-        <p:style>
-          <a:lnRef idx="2">
-            <a:schemeClr val="accent1"/>
-          </a:lnRef>
-          <a:fillRef idx="0">
-            <a:schemeClr val="accent1"/>
-          </a:fillRef>
-          <a:effectRef idx="1">
-            <a:schemeClr val="accent1"/>
-          </a:effectRef>
-          <a:fontRef idx="minor">
-            <a:schemeClr val="tx1"/>
-          </a:fontRef>
-        </p:style>
       </p:cxnSp>
       <p:sp>
         <p:nvSpPr>
@@ -10232,25 +9281,11 @@
           </a:solidFill>
           <a:ln w="19050">
             <a:solidFill>
-              <a:srgbClr val="B2182B"/>
+              <a:srgbClr val="1F3A5F"/>
             </a:solidFill>
           </a:ln>
           <a:effectLst/>
         </p:spPr>
-        <p:style>
-          <a:lnRef idx="1">
-            <a:schemeClr val="accent1"/>
-          </a:lnRef>
-          <a:fillRef idx="3">
-            <a:schemeClr val="accent1"/>
-          </a:fillRef>
-          <a:effectRef idx="2">
-            <a:schemeClr val="accent1"/>
-          </a:effectRef>
-          <a:fontRef idx="minor">
-            <a:schemeClr val="lt1"/>
-          </a:fontRef>
-        </p:style>
         <p:txBody>
           <a:bodyPr rtlCol="0" anchor="ctr" wrap="square" lIns="73152" rIns="73152" tIns="27432" bIns="27432"/>
           <a:lstStyle/>
@@ -10259,7 +9294,7 @@
             <a:r>
               <a:rPr sz="1600" b="1">
                 <a:solidFill>
-                  <a:srgbClr val="B2182B"/>
+                  <a:srgbClr val="1F3A5F"/>
                 </a:solidFill>
                 <a:latin typeface="Arial"/>
               </a:rPr>
@@ -10301,25 +9336,11 @@
           </a:solidFill>
           <a:ln w="19050">
             <a:solidFill>
-              <a:srgbClr val="B2182B"/>
+              <a:srgbClr val="1F3A5F"/>
             </a:solidFill>
           </a:ln>
           <a:effectLst/>
         </p:spPr>
-        <p:style>
-          <a:lnRef idx="1">
-            <a:schemeClr val="accent1"/>
-          </a:lnRef>
-          <a:fillRef idx="3">
-            <a:schemeClr val="accent1"/>
-          </a:fillRef>
-          <a:effectRef idx="2">
-            <a:schemeClr val="accent1"/>
-          </a:effectRef>
-          <a:fontRef idx="minor">
-            <a:schemeClr val="lt1"/>
-          </a:fontRef>
-        </p:style>
         <p:txBody>
           <a:bodyPr rtlCol="0" anchor="ctr" wrap="square" lIns="73152" rIns="73152" tIns="27432" bIns="27432"/>
           <a:lstStyle/>
@@ -10328,7 +9349,7 @@
             <a:r>
               <a:rPr sz="1600" b="1">
                 <a:solidFill>
-                  <a:srgbClr val="B2182B"/>
+                  <a:srgbClr val="1F3A5F"/>
                 </a:solidFill>
                 <a:latin typeface="Arial"/>
               </a:rPr>
@@ -10379,7 +9400,7 @@
                 </a:solidFill>
                 <a:latin typeface="Arial"/>
               </a:rPr>
-              <a:t>Same score, different story - spatial-frequency features for AI-generated image detection</a:t>
+              <a:t>CSE 4883 Digital Image Processing  ·  Same score, different story</a:t>
             </a:r>
           </a:p>
         </p:txBody>
@@ -10458,20 +9479,6 @@
             <a:noFill/>
           </a:ln>
         </p:spPr>
-        <p:style>
-          <a:lnRef idx="1">
-            <a:schemeClr val="accent1"/>
-          </a:lnRef>
-          <a:fillRef idx="3">
-            <a:schemeClr val="accent1"/>
-          </a:fillRef>
-          <a:effectRef idx="2">
-            <a:schemeClr val="accent1"/>
-          </a:effectRef>
-          <a:fontRef idx="minor">
-            <a:schemeClr val="lt1"/>
-          </a:fontRef>
-        </p:style>
         <p:txBody>
           <a:bodyPr rtlCol="0" anchor="ctr"/>
           <a:lstStyle/>
@@ -10506,7 +9513,7 @@
             <a:r>
               <a:rPr sz="1050" b="0" i="0">
                 <a:solidFill>
-                  <a:srgbClr val="A9B4C0"/>
+                  <a:srgbClr val="5D6D7E"/>
                 </a:solidFill>
                 <a:latin typeface="Arial"/>
               </a:rPr>
@@ -10571,20 +9578,6 @@
             <a:noFill/>
           </a:ln>
         </p:spPr>
-        <p:style>
-          <a:lnRef idx="1">
-            <a:schemeClr val="accent1"/>
-          </a:lnRef>
-          <a:fillRef idx="3">
-            <a:schemeClr val="accent1"/>
-          </a:fillRef>
-          <a:effectRef idx="2">
-            <a:schemeClr val="accent1"/>
-          </a:effectRef>
-          <a:fontRef idx="minor">
-            <a:schemeClr val="lt1"/>
-          </a:fontRef>
-        </p:style>
         <p:txBody>
           <a:bodyPr rtlCol="0" anchor="ctr"/>
           <a:lstStyle/>
@@ -10619,7 +9612,7 @@
             <a:r>
               <a:rPr sz="1050" b="0" i="0">
                 <a:solidFill>
-                  <a:srgbClr val="A9B4C0"/>
+                  <a:srgbClr val="5D6D7E"/>
                 </a:solidFill>
                 <a:latin typeface="Arial"/>
               </a:rPr>
@@ -10654,7 +9647,7 @@
             <a:r>
               <a:rPr sz="1050" b="0" i="0">
                 <a:solidFill>
-                  <a:srgbClr val="A9B4C0"/>
+                  <a:srgbClr val="5D6D7E"/>
                 </a:solidFill>
                 <a:latin typeface="Arial"/>
               </a:rPr>
@@ -10689,7 +9682,7 @@
             <a:r>
               <a:rPr sz="1050" b="0" i="0">
                 <a:solidFill>
-                  <a:srgbClr val="A9B4C0"/>
+                  <a:srgbClr val="5D6D7E"/>
                 </a:solidFill>
                 <a:latin typeface="Arial"/>
               </a:rPr>
@@ -10724,7 +9717,7 @@
             <a:r>
               <a:rPr sz="1050" b="0" i="0">
                 <a:solidFill>
-                  <a:srgbClr val="A9B4C0"/>
+                  <a:srgbClr val="5D6D7E"/>
                 </a:solidFill>
                 <a:latin typeface="Arial"/>
               </a:rPr>
@@ -10759,7 +9752,7 @@
             <a:r>
               <a:rPr sz="1050" b="0" i="0">
                 <a:solidFill>
-                  <a:srgbClr val="A9B4C0"/>
+                  <a:srgbClr val="5D6D7E"/>
                 </a:solidFill>
                 <a:latin typeface="Arial"/>
               </a:rPr>
@@ -10789,20 +9782,6 @@
             <a:noFill/>
           </a:ln>
         </p:spPr>
-        <p:style>
-          <a:lnRef idx="1">
-            <a:schemeClr val="accent1"/>
-          </a:lnRef>
-          <a:fillRef idx="3">
-            <a:schemeClr val="accent1"/>
-          </a:fillRef>
-          <a:effectRef idx="2">
-            <a:schemeClr val="accent1"/>
-          </a:effectRef>
-          <a:fontRef idx="minor">
-            <a:schemeClr val="lt1"/>
-          </a:fontRef>
-        </p:style>
         <p:txBody>
           <a:bodyPr rtlCol="0" anchor="ctr"/>
           <a:lstStyle/>
@@ -10820,7 +9799,7 @@
         <p:spPr>
           <a:xfrm>
             <a:off x="548640" y="713232"/>
-            <a:ext cx="9509760" cy="548640"/>
+            <a:ext cx="9418320" cy="548640"/>
           </a:xfrm>
           <a:prstGeom prst="rect">
             <a:avLst/>
@@ -10854,8 +9833,8 @@
         </p:nvSpPr>
         <p:spPr>
           <a:xfrm>
-            <a:off x="9997135" y="822960"/>
-            <a:ext cx="1645920" cy="274320"/>
+            <a:off x="10271455" y="822960"/>
+            <a:ext cx="1371600" cy="274320"/>
           </a:xfrm>
           <a:prstGeom prst="rect">
             <a:avLst/>
@@ -10883,177 +9862,158 @@
       </p:sp>
       <p:sp>
         <p:nvSpPr>
-          <p:cNvPr id="14" name="Rounded Rectangle 13"/>
+          <p:cNvPr id="14" name="TextBox 13"/>
+          <p:cNvSpPr txBox="1"/>
+          <p:nvPr/>
+        </p:nvSpPr>
+        <p:spPr>
+          <a:xfrm>
+            <a:off x="548640" y="1600200"/>
+            <a:ext cx="4754880" cy="2651760"/>
+          </a:xfrm>
+          <a:prstGeom prst="rect">
+            <a:avLst/>
+          </a:prstGeom>
+          <a:noFill/>
+        </p:spPr>
+        <p:txBody>
+          <a:bodyPr wrap="square" lIns="0" rIns="0" tIns="0" bIns="0">
+            <a:spAutoFit/>
+          </a:bodyPr>
+          <a:lstStyle/>
+          <a:p>
+            <a:pPr algn="l">
+              <a:lnSpc>
+                <a:spcPct val="125000"/>
+              </a:lnSpc>
+            </a:pPr>
+            <a:r>
+              <a:rPr sz="2400" b="0">
+                <a:solidFill>
+                  <a:srgbClr val="1C2833"/>
+                </a:solidFill>
+                <a:latin typeface="Georgia"/>
+              </a:rPr>
+              <a:t>Give every image the same resampling. The pooled AUROC barely moves (</a:t>
+            </a:r>
+            <a:r>
+              <a:rPr sz="2400" b="1">
+                <a:solidFill>
+                  <a:srgbClr val="1F3A5F"/>
+                </a:solidFill>
+                <a:latin typeface="Arial"/>
+              </a:rPr>
+              <a:t>0.796 → 0.802</a:t>
+            </a:r>
+            <a:r>
+              <a:rPr sz="2400" b="0">
+                <a:solidFill>
+                  <a:srgbClr val="1C2833"/>
+                </a:solidFill>
+                <a:latin typeface="Georgia"/>
+              </a:rPr>
+              <a:t>), but per-generator AUROC shifts by </a:t>
+            </a:r>
+            <a:r>
+              <a:rPr sz="2400" b="1">
+                <a:solidFill>
+                  <a:srgbClr val="B2182B"/>
+                </a:solidFill>
+                <a:latin typeface="Arial"/>
+              </a:rPr>
+              <a:t>−0.17 to +0.30</a:t>
+            </a:r>
+            <a:r>
+              <a:rPr sz="2400" b="0">
+                <a:solidFill>
+                  <a:srgbClr val="1C2833"/>
+                </a:solidFill>
+                <a:latin typeface="Georgia"/>
+              </a:rPr>
+              <a:t>.</a:t>
+            </a:r>
+          </a:p>
+        </p:txBody>
+      </p:sp>
+      <p:sp>
+        <p:nvSpPr>
+          <p:cNvPr id="15" name="Rectangle 14"/>
           <p:cNvSpPr/>
           <p:nvPr/>
         </p:nvSpPr>
         <p:spPr>
           <a:xfrm>
-            <a:off x="548640" y="1463040"/>
-            <a:ext cx="4480560" cy="2057400"/>
-          </a:xfrm>
-          <a:prstGeom prst="roundRect">
-            <a:avLst>
-              <a:gd name="adj" fmla="val 12000"/>
-            </a:avLst>
+            <a:off x="548640" y="4343400"/>
+            <a:ext cx="4754880" cy="9525"/>
+          </a:xfrm>
+          <a:prstGeom prst="rect">
+            <a:avLst/>
           </a:prstGeom>
           <a:solidFill>
-            <a:srgbClr val="FFFFFF"/>
+            <a:srgbClr val="D5DBDB"/>
           </a:solidFill>
-          <a:ln w="12700">
-            <a:solidFill>
-              <a:srgbClr val="D5DBDB"/>
-            </a:solidFill>
+          <a:ln>
+            <a:noFill/>
           </a:ln>
-          <a:effectLst/>
-        </p:spPr>
-        <p:style>
-          <a:lnRef idx="1">
-            <a:schemeClr val="accent1"/>
-          </a:lnRef>
-          <a:fillRef idx="3">
-            <a:schemeClr val="accent1"/>
-          </a:fillRef>
-          <a:effectRef idx="2">
-            <a:schemeClr val="accent1"/>
-          </a:effectRef>
-          <a:fontRef idx="minor">
-            <a:schemeClr val="lt1"/>
-          </a:fontRef>
-        </p:style>
-        <p:txBody>
-          <a:bodyPr rtlCol="0" anchor="ctr" wrap="square" lIns="73152" rIns="73152" tIns="27432" bIns="27432"/>
+        </p:spPr>
+        <p:txBody>
+          <a:bodyPr rtlCol="0" anchor="ctr"/>
           <a:lstStyle/>
           <a:p>
             <a:pPr algn="ctr"/>
-            <a:r>
-              <a:rPr sz="4000" b="1">
-                <a:solidFill>
-                  <a:srgbClr val="1F3A5F"/>
-                </a:solidFill>
-                <a:latin typeface="Arial"/>
-              </a:rPr>
-              <a:t>0.796 → 0.802</a:t>
-            </a:r>
-          </a:p>
-          <a:p>
-            <a:pPr algn="ctr"/>
-            <a:r>
-              <a:rPr sz="1300" b="0">
-                <a:solidFill>
-                  <a:srgbClr val="5D6D7E"/>
-                </a:solidFill>
-                <a:latin typeface="Arial"/>
-              </a:rPr>
-              <a:t>pooled AUROC when every image gets</a:t>
-            </a:r>
-          </a:p>
-          <a:p>
-            <a:pPr algn="ctr"/>
-            <a:r>
-              <a:rPr sz="1300" b="0">
-                <a:solidFill>
-                  <a:srgbClr val="5D6D7E"/>
-                </a:solidFill>
-                <a:latin typeface="Arial"/>
-              </a:rPr>
-              <a:t>the same resampling: the score stays</a:t>
-            </a:r>
-          </a:p>
-        </p:txBody>
-      </p:sp>
-      <p:sp>
-        <p:nvSpPr>
-          <p:cNvPr id="15" name="Rounded Rectangle 14"/>
-          <p:cNvSpPr/>
-          <p:nvPr/>
-        </p:nvSpPr>
-        <p:spPr>
-          <a:xfrm>
-            <a:off x="548640" y="3703320"/>
-            <a:ext cx="4480560" cy="2057400"/>
-          </a:xfrm>
-          <a:prstGeom prst="roundRect">
-            <a:avLst>
-              <a:gd name="adj" fmla="val 12000"/>
-            </a:avLst>
-          </a:prstGeom>
-          <a:solidFill>
-            <a:srgbClr val="FFFFFF"/>
-          </a:solidFill>
-          <a:ln w="19050">
-            <a:solidFill>
-              <a:srgbClr val="B2182B"/>
-            </a:solidFill>
-          </a:ln>
-          <a:effectLst/>
-        </p:spPr>
-        <p:style>
-          <a:lnRef idx="1">
-            <a:schemeClr val="accent1"/>
-          </a:lnRef>
-          <a:fillRef idx="3">
-            <a:schemeClr val="accent1"/>
-          </a:fillRef>
-          <a:effectRef idx="2">
-            <a:schemeClr val="accent1"/>
-          </a:effectRef>
-          <a:fontRef idx="minor">
-            <a:schemeClr val="lt1"/>
-          </a:fontRef>
-        </p:style>
-        <p:txBody>
-          <a:bodyPr rtlCol="0" anchor="ctr" wrap="square" lIns="73152" rIns="73152" tIns="27432" bIns="27432"/>
-          <a:lstStyle/>
-          <a:p>
-            <a:pPr algn="ctr"/>
-            <a:r>
-              <a:rPr sz="4000" b="1">
-                <a:solidFill>
-                  <a:srgbClr val="B2182B"/>
-                </a:solidFill>
-                <a:latin typeface="Arial"/>
-              </a:rPr>
-              <a:t>-0.17 to +0.30</a:t>
-            </a:r>
-          </a:p>
-          <a:p>
-            <a:pPr algn="ctr"/>
-            <a:r>
-              <a:rPr sz="1300" b="0">
-                <a:solidFill>
-                  <a:srgbClr val="5D6D7E"/>
-                </a:solidFill>
-                <a:latin typeface="Arial"/>
-              </a:rPr>
-              <a:t>change in per-generator AUROC</a:t>
-            </a:r>
-          </a:p>
-          <a:p>
-            <a:pPr algn="ctr"/>
-            <a:r>
-              <a:rPr sz="1300" b="0">
-                <a:solidFill>
-                  <a:srgbClr val="5D6D7E"/>
-                </a:solidFill>
-                <a:latin typeface="Arial"/>
-              </a:rPr>
-              <a:t>from the same swap: the story changes</a:t>
+          </a:p>
+        </p:txBody>
+      </p:sp>
+      <p:sp>
+        <p:nvSpPr>
+          <p:cNvPr id="16" name="TextBox 15"/>
+          <p:cNvSpPr txBox="1"/>
+          <p:nvPr/>
+        </p:nvSpPr>
+        <p:spPr>
+          <a:xfrm>
+            <a:off x="548640" y="4526280"/>
+            <a:ext cx="4754880" cy="1188720"/>
+          </a:xfrm>
+          <a:prstGeom prst="rect">
+            <a:avLst/>
+          </a:prstGeom>
+          <a:noFill/>
+        </p:spPr>
+        <p:txBody>
+          <a:bodyPr wrap="square" lIns="0" rIns="0" tIns="0" bIns="0">
+            <a:spAutoFit/>
+          </a:bodyPr>
+          <a:lstStyle/>
+          <a:p>
+            <a:pPr algn="l">
+              <a:lnSpc>
+                <a:spcPct val="120000"/>
+              </a:lnSpc>
+            </a:pPr>
+            <a:r>
+              <a:rPr sz="1500" b="0" i="0">
+                <a:solidFill>
+                  <a:srgbClr val="1C2833"/>
+                </a:solidFill>
+                <a:latin typeface="Arial"/>
+              </a:rPr>
+              <a:t>BigGAN images are pixel-identical in both versions, so any change in BigGAN comes from the real photos' processing alone.</a:t>
             </a:r>
           </a:p>
         </p:txBody>
       </p:sp>
       <p:graphicFrame>
         <p:nvGraphicFramePr>
-          <p:cNvPr id="16" name="Table 15"/>
+          <p:cNvPr id="17" name="Table 16"/>
           <p:cNvGraphicFramePr>
             <a:graphicFrameLocks noGrp="1"/>
           </p:cNvGraphicFramePr>
           <p:nvPr/>
         </p:nvGraphicFramePr>
         <p:xfrm>
-          <a:off x="5349240" y="1463040"/>
-          <a:ext cx="6309360" cy="2743200"/>
+          <a:off x="5577840" y="1600200"/>
+          <a:ext cx="6062472" cy="2834640"/>
         </p:xfrm>
         <a:graphic>
           <a:graphicData uri="http://schemas.openxmlformats.org/drawingml/2006/table">
@@ -11062,11 +10022,11 @@
                 <a:tableStyleId>{5C22544A-7EE6-4342-B048-85BDC9FD1C3A}</a:tableStyleId>
               </a:tblPr>
               <a:tblGrid>
-                <a:gridCol w="1645920"/>
-                <a:gridCol w="1783080"/>
-                <a:gridCol w="2880360"/>
+                <a:gridCol w="1463040"/>
+                <a:gridCol w="1737360"/>
+                <a:gridCol w="2862072"/>
               </a:tblGrid>
-              <a:tr h="548640">
+              <a:tr h="566928">
                 <a:tc>
                   <a:txBody>
                     <a:bodyPr wrap="square"/>
@@ -11152,7 +10112,7 @@
                   </a:tcPr>
                 </a:tc>
               </a:tr>
-              <a:tr h="548640">
+              <a:tr h="566928">
                 <a:tc>
                   <a:txBody>
                     <a:bodyPr wrap="square"/>
@@ -11238,7 +10198,7 @@
                   </a:tcPr>
                 </a:tc>
               </a:tr>
-              <a:tr h="548640">
+              <a:tr h="566928">
                 <a:tc>
                   <a:txBody>
                     <a:bodyPr wrap="square"/>
@@ -11324,7 +10284,7 @@
                   </a:tcPr>
                 </a:tc>
               </a:tr>
-              <a:tr h="548640">
+              <a:tr h="566928">
                 <a:tc>
                   <a:txBody>
                     <a:bodyPr wrap="square"/>
@@ -11410,7 +10370,7 @@
                   </a:tcPr>
                 </a:tc>
               </a:tr>
-              <a:tr h="548640">
+              <a:tr h="566928">
                 <a:tc>
                   <a:txBody>
                     <a:bodyPr wrap="square"/>
@@ -11480,17 +10440,7 @@
                           </a:solidFill>
                           <a:latin typeface="Arial"/>
                         </a:rPr>
-                        <a:t>resampling isolated</a:t>
-                      </a:r>
-                      <a:br/>
-                      <a:r>
-                        <a:rPr sz="1250" b="1">
-                          <a:solidFill>
-                            <a:srgbClr val="B2182B"/>
-                          </a:solidFill>
-                          <a:latin typeface="Arial"/>
-                        </a:rPr>
-                        <a:t>+ matched JPEG + unseen generator</a:t>
+                        <a:t>resampling (isolated), matched JPEG, unseen generator</a:t>
                       </a:r>
                     </a:p>
                   </a:txBody>
@@ -11512,14 +10462,14 @@
       </p:graphicFrame>
       <p:sp>
         <p:nvSpPr>
-          <p:cNvPr id="17" name="TextBox 16"/>
-          <p:cNvSpPr txBox="1"/>
-          <p:nvPr/>
-        </p:nvSpPr>
-        <p:spPr>
-          <a:xfrm>
-            <a:off x="5349240" y="4846320"/>
-            <a:ext cx="6309360" cy="914400"/>
+          <p:cNvPr id="18" name="TextBox 17"/>
+          <p:cNvSpPr txBox="1"/>
+          <p:nvPr/>
+        </p:nvSpPr>
+        <p:spPr>
+          <a:xfrm>
+            <a:off x="5577840" y="4846320"/>
+            <a:ext cx="6062472" cy="548640"/>
           </a:xfrm>
           <a:prstGeom prst="rect">
             <a:avLst/>
@@ -11540,34 +10490,18 @@
             <a:r>
               <a:rPr sz="1300" b="0" i="0">
                 <a:solidFill>
-                  <a:srgbClr val="1C2833"/>
-                </a:solidFill>
-                <a:latin typeface="Arial"/>
-              </a:rPr>
-              <a:t>The BigGAN images are pixel-identical in both versions, so any change in BigGAN comes from the real photos' processing alone.</a:t>
-            </a:r>
-          </a:p>
-          <a:p>
-            <a:pPr algn="l">
-              <a:lnSpc>
-                <a:spcPct val="115000"/>
-              </a:lnSpc>
-            </a:pPr>
-            <a:r>
-              <a:rPr sz="1300" b="0" i="0">
-                <a:solidFill>
-                  <a:srgbClr val="1C2833"/>
-                </a:solidFill>
-                <a:latin typeface="Arial"/>
-              </a:rPr>
-              <a:t>We found no report of this feature-level protocol (we do not claim 'first').</a:t>
-            </a:r>
-          </a:p>
-        </p:txBody>
-      </p:sp>
-      <p:sp>
-        <p:nvSpPr>
-          <p:cNvPr id="18" name="TextBox 17"/>
+                  <a:srgbClr val="5D6D7E"/>
+                </a:solidFill>
+                <a:latin typeface="Arial"/>
+              </a:rPr>
+              <a:t>We found no report of this feature-level protocol; we say “not found”, not “first”.</a:t>
+            </a:r>
+          </a:p>
+        </p:txBody>
+      </p:sp>
+      <p:sp>
+        <p:nvSpPr>
+          <p:cNvPr id="19" name="TextBox 18"/>
           <p:cNvSpPr txBox="1"/>
           <p:nvPr/>
         </p:nvSpPr>
@@ -11595,14 +10529,14 @@
                 </a:solidFill>
                 <a:latin typeface="Arial"/>
               </a:rPr>
-              <a:t>Same score, different story - spatial-frequency features for AI-generated image detection</a:t>
-            </a:r>
-          </a:p>
-        </p:txBody>
-      </p:sp>
-      <p:sp>
-        <p:nvSpPr>
-          <p:cNvPr id="19" name="TextBox 18"/>
+              <a:t>CSE 4883 Digital Image Processing  ·  Same score, different story</a:t>
+            </a:r>
+          </a:p>
+        </p:txBody>
+      </p:sp>
+      <p:sp>
+        <p:nvSpPr>
+          <p:cNvPr id="20" name="TextBox 19"/>
           <p:cNvSpPr txBox="1"/>
           <p:nvPr/>
         </p:nvSpPr>
@@ -11679,7 +10613,7 @@
             <a:r>
               <a:rPr sz="1050" b="0" i="0">
                 <a:solidFill>
-                  <a:srgbClr val="A9B4C0"/>
+                  <a:srgbClr val="5D6D7E"/>
                 </a:solidFill>
                 <a:latin typeface="Arial"/>
               </a:rPr>
@@ -11714,7 +10648,7 @@
             <a:r>
               <a:rPr sz="1050" b="0" i="0">
                 <a:solidFill>
-                  <a:srgbClr val="A9B4C0"/>
+                  <a:srgbClr val="5D6D7E"/>
                 </a:solidFill>
                 <a:latin typeface="Arial"/>
               </a:rPr>
@@ -11779,20 +10713,6 @@
             <a:noFill/>
           </a:ln>
         </p:spPr>
-        <p:style>
-          <a:lnRef idx="1">
-            <a:schemeClr val="accent1"/>
-          </a:lnRef>
-          <a:fillRef idx="3">
-            <a:schemeClr val="accent1"/>
-          </a:fillRef>
-          <a:effectRef idx="2">
-            <a:schemeClr val="accent1"/>
-          </a:effectRef>
-          <a:fontRef idx="minor">
-            <a:schemeClr val="lt1"/>
-          </a:fontRef>
-        </p:style>
         <p:txBody>
           <a:bodyPr rtlCol="0" anchor="ctr"/>
           <a:lstStyle/>
@@ -11827,7 +10747,7 @@
             <a:r>
               <a:rPr sz="1050" b="0" i="0">
                 <a:solidFill>
-                  <a:srgbClr val="A9B4C0"/>
+                  <a:srgbClr val="5D6D7E"/>
                 </a:solidFill>
                 <a:latin typeface="Arial"/>
               </a:rPr>
@@ -11862,7 +10782,7 @@
             <a:r>
               <a:rPr sz="1050" b="0" i="0">
                 <a:solidFill>
-                  <a:srgbClr val="A9B4C0"/>
+                  <a:srgbClr val="5D6D7E"/>
                 </a:solidFill>
                 <a:latin typeface="Arial"/>
               </a:rPr>
@@ -11897,7 +10817,7 @@
             <a:r>
               <a:rPr sz="1050" b="0" i="0">
                 <a:solidFill>
-                  <a:srgbClr val="A9B4C0"/>
+                  <a:srgbClr val="5D6D7E"/>
                 </a:solidFill>
                 <a:latin typeface="Arial"/>
               </a:rPr>
@@ -11932,7 +10852,7 @@
             <a:r>
               <a:rPr sz="1050" b="0" i="0">
                 <a:solidFill>
-                  <a:srgbClr val="A9B4C0"/>
+                  <a:srgbClr val="5D6D7E"/>
                 </a:solidFill>
                 <a:latin typeface="Arial"/>
               </a:rPr>
@@ -11962,20 +10882,6 @@
             <a:noFill/>
           </a:ln>
         </p:spPr>
-        <p:style>
-          <a:lnRef idx="1">
-            <a:schemeClr val="accent1"/>
-          </a:lnRef>
-          <a:fillRef idx="3">
-            <a:schemeClr val="accent1"/>
-          </a:fillRef>
-          <a:effectRef idx="2">
-            <a:schemeClr val="accent1"/>
-          </a:effectRef>
-          <a:fontRef idx="minor">
-            <a:schemeClr val="lt1"/>
-          </a:fontRef>
-        </p:style>
         <p:txBody>
           <a:bodyPr rtlCol="0" anchor="ctr"/>
           <a:lstStyle/>
@@ -11993,7 +10899,7 @@
         <p:spPr>
           <a:xfrm>
             <a:off x="548640" y="713232"/>
-            <a:ext cx="9509760" cy="548640"/>
+            <a:ext cx="9418320" cy="548640"/>
           </a:xfrm>
           <a:prstGeom prst="rect">
             <a:avLst/>
@@ -12027,8 +10933,8 @@
         </p:nvSpPr>
         <p:spPr>
           <a:xfrm>
-            <a:off x="9997135" y="822960"/>
-            <a:ext cx="1645920" cy="274320"/>
+            <a:off x="10271455" y="822960"/>
+            <a:ext cx="1371600" cy="274320"/>
           </a:xfrm>
           <a:prstGeom prst="rect">
             <a:avLst/>
@@ -12105,20 +11011,6 @@
           </a:ln>
           <a:effectLst/>
         </p:spPr>
-        <p:style>
-          <a:lnRef idx="1">
-            <a:schemeClr val="accent1"/>
-          </a:lnRef>
-          <a:fillRef idx="3">
-            <a:schemeClr val="accent1"/>
-          </a:fillRef>
-          <a:effectRef idx="2">
-            <a:schemeClr val="accent1"/>
-          </a:effectRef>
-          <a:fontRef idx="minor">
-            <a:schemeClr val="lt1"/>
-          </a:fontRef>
-        </p:style>
         <p:txBody>
           <a:bodyPr rtlCol="0" anchor="ctr"/>
           <a:lstStyle/>
@@ -12200,7 +11092,7 @@
                 </a:solidFill>
                 <a:latin typeface="Arial"/>
               </a:rPr>
-              <a:t>1,500 real  -  500 each: BigGAN, SD v1.4, ADM</a:t>
+              <a:t>1,500 real  ·  500 each: BigGAN, SD v1.4, ADM</a:t>
             </a:r>
           </a:p>
         </p:txBody>
@@ -12227,20 +11119,6 @@
           </a:ln>
           <a:effectLst/>
         </p:spPr>
-        <p:style>
-          <a:lnRef idx="1">
-            <a:schemeClr val="accent1"/>
-          </a:lnRef>
-          <a:fillRef idx="3">
-            <a:schemeClr val="accent1"/>
-          </a:fillRef>
-          <a:effectRef idx="2">
-            <a:schemeClr val="accent1"/>
-          </a:effectRef>
-          <a:fontRef idx="minor">
-            <a:schemeClr val="lt1"/>
-          </a:fontRef>
-        </p:style>
         <p:txBody>
           <a:bodyPr rtlCol="0" anchor="ctr"/>
           <a:lstStyle/>
@@ -12349,20 +11227,6 @@
           </a:ln>
           <a:effectLst/>
         </p:spPr>
-        <p:style>
-          <a:lnRef idx="1">
-            <a:schemeClr val="accent1"/>
-          </a:lnRef>
-          <a:fillRef idx="3">
-            <a:schemeClr val="accent1"/>
-          </a:fillRef>
-          <a:effectRef idx="2">
-            <a:schemeClr val="accent1"/>
-          </a:effectRef>
-          <a:fontRef idx="minor">
-            <a:schemeClr val="lt1"/>
-          </a:fontRef>
-        </p:style>
         <p:txBody>
           <a:bodyPr rtlCol="0" anchor="ctr"/>
           <a:lstStyle/>
@@ -12444,7 +11308,7 @@
                 </a:solidFill>
                 <a:latin typeface="Arial"/>
               </a:rPr>
-              <a:t>resize to 256 x 256, lossless PNG</a:t>
+              <a:t>resize to 256 × 256, lossless PNG</a:t>
             </a:r>
           </a:p>
         </p:txBody>
@@ -12471,20 +11335,6 @@
           </a:ln>
           <a:effectLst/>
         </p:spPr>
-        <p:style>
-          <a:lnRef idx="1">
-            <a:schemeClr val="accent1"/>
-          </a:lnRef>
-          <a:fillRef idx="3">
-            <a:schemeClr val="accent1"/>
-          </a:fillRef>
-          <a:effectRef idx="2">
-            <a:schemeClr val="accent1"/>
-          </a:effectRef>
-          <a:fontRef idx="minor">
-            <a:schemeClr val="lt1"/>
-          </a:fontRef>
-        </p:style>
         <p:txBody>
           <a:bodyPr rtlCol="0" anchor="ctr"/>
           <a:lstStyle/>
@@ -12566,7 +11416,7 @@
                 </a:solidFill>
                 <a:latin typeface="Arial"/>
               </a:rPr>
-              <a:t>C0 clean  -  C1 JPEG 90/75/50  -  C2 unfair control</a:t>
+              <a:t>C0 clean  ·  C1 JPEG 90 / 75 / 50  ·  C2 unfair control</a:t>
             </a:r>
           </a:p>
         </p:txBody>
@@ -12593,20 +11443,6 @@
           </a:ln>
           <a:effectLst/>
         </p:spPr>
-        <p:style>
-          <a:lnRef idx="1">
-            <a:schemeClr val="accent1"/>
-          </a:lnRef>
-          <a:fillRef idx="3">
-            <a:schemeClr val="accent1"/>
-          </a:fillRef>
-          <a:effectRef idx="2">
-            <a:schemeClr val="accent1"/>
-          </a:effectRef>
-          <a:fontRef idx="minor">
-            <a:schemeClr val="lt1"/>
-          </a:fontRef>
-        </p:style>
         <p:txBody>
           <a:bodyPr rtlCol="0" anchor="ctr"/>
           <a:lstStyle/>
@@ -12688,7 +11524,7 @@
                 </a:solidFill>
                 <a:latin typeface="Arial"/>
               </a:rPr>
-              <a:t>split by image group  -  one locked 600-image test set  -  95% CIs</a:t>
+              <a:t>split by image group  ·  one locked 600-image test set  ·  95% CIs</a:t>
             </a:r>
           </a:p>
         </p:txBody>
@@ -12723,7 +11559,7 @@
                 </a:solidFill>
                 <a:latin typeface="Arial"/>
               </a:rPr>
-              <a:t>Same score, different story - spatial-frequency features for AI-generated image detection</a:t>
+              <a:t>CSE 4883 Digital Image Processing  ·  Same score, different story</a:t>
             </a:r>
           </a:p>
         </p:txBody>
@@ -12807,7 +11643,7 @@
             <a:r>
               <a:rPr sz="1050" b="0" i="0">
                 <a:solidFill>
-                  <a:srgbClr val="A9B4C0"/>
+                  <a:srgbClr val="5D6D7E"/>
                 </a:solidFill>
                 <a:latin typeface="Arial"/>
               </a:rPr>
@@ -12842,7 +11678,7 @@
             <a:r>
               <a:rPr sz="1050" b="0" i="0">
                 <a:solidFill>
-                  <a:srgbClr val="A9B4C0"/>
+                  <a:srgbClr val="5D6D7E"/>
                 </a:solidFill>
                 <a:latin typeface="Arial"/>
               </a:rPr>
@@ -12907,20 +11743,6 @@
             <a:noFill/>
           </a:ln>
         </p:spPr>
-        <p:style>
-          <a:lnRef idx="1">
-            <a:schemeClr val="accent1"/>
-          </a:lnRef>
-          <a:fillRef idx="3">
-            <a:schemeClr val="accent1"/>
-          </a:fillRef>
-          <a:effectRef idx="2">
-            <a:schemeClr val="accent1"/>
-          </a:effectRef>
-          <a:fontRef idx="minor">
-            <a:schemeClr val="lt1"/>
-          </a:fontRef>
-        </p:style>
         <p:txBody>
           <a:bodyPr rtlCol="0" anchor="ctr"/>
           <a:lstStyle/>
@@ -12955,7 +11777,7 @@
             <a:r>
               <a:rPr sz="1050" b="0" i="0">
                 <a:solidFill>
-                  <a:srgbClr val="A9B4C0"/>
+                  <a:srgbClr val="5D6D7E"/>
                 </a:solidFill>
                 <a:latin typeface="Arial"/>
               </a:rPr>
@@ -12990,7 +11812,7 @@
             <a:r>
               <a:rPr sz="1050" b="0" i="0">
                 <a:solidFill>
-                  <a:srgbClr val="A9B4C0"/>
+                  <a:srgbClr val="5D6D7E"/>
                 </a:solidFill>
                 <a:latin typeface="Arial"/>
               </a:rPr>
@@ -13025,7 +11847,7 @@
             <a:r>
               <a:rPr sz="1050" b="0" i="0">
                 <a:solidFill>
-                  <a:srgbClr val="A9B4C0"/>
+                  <a:srgbClr val="5D6D7E"/>
                 </a:solidFill>
                 <a:latin typeface="Arial"/>
               </a:rPr>
@@ -13060,7 +11882,7 @@
             <a:r>
               <a:rPr sz="1050" b="0" i="0">
                 <a:solidFill>
-                  <a:srgbClr val="A9B4C0"/>
+                  <a:srgbClr val="5D6D7E"/>
                 </a:solidFill>
                 <a:latin typeface="Arial"/>
               </a:rPr>
@@ -13090,20 +11912,6 @@
             <a:noFill/>
           </a:ln>
         </p:spPr>
-        <p:style>
-          <a:lnRef idx="1">
-            <a:schemeClr val="accent1"/>
-          </a:lnRef>
-          <a:fillRef idx="3">
-            <a:schemeClr val="accent1"/>
-          </a:fillRef>
-          <a:effectRef idx="2">
-            <a:schemeClr val="accent1"/>
-          </a:effectRef>
-          <a:fontRef idx="minor">
-            <a:schemeClr val="lt1"/>
-          </a:fontRef>
-        </p:style>
         <p:txBody>
           <a:bodyPr rtlCol="0" anchor="ctr"/>
           <a:lstStyle/>
@@ -13121,7 +11929,7 @@
         <p:spPr>
           <a:xfrm>
             <a:off x="548640" y="713232"/>
-            <a:ext cx="9509760" cy="548640"/>
+            <a:ext cx="9418320" cy="548640"/>
           </a:xfrm>
           <a:prstGeom prst="rect">
             <a:avLst/>
@@ -13155,8 +11963,8 @@
         </p:nvSpPr>
         <p:spPr>
           <a:xfrm>
-            <a:off x="9997135" y="822960"/>
-            <a:ext cx="1645920" cy="274320"/>
+            <a:off x="10271455" y="822960"/>
+            <a:ext cx="1371600" cy="274320"/>
           </a:xfrm>
           <a:prstGeom prst="rect">
             <a:avLst/>
@@ -13237,20 +12045,6 @@
           </a:ln>
           <a:effectLst/>
         </p:spPr>
-        <p:style>
-          <a:lnRef idx="1">
-            <a:schemeClr val="accent1"/>
-          </a:lnRef>
-          <a:fillRef idx="3">
-            <a:schemeClr val="accent1"/>
-          </a:fillRef>
-          <a:effectRef idx="2">
-            <a:schemeClr val="accent1"/>
-          </a:effectRef>
-          <a:fontRef idx="minor">
-            <a:schemeClr val="lt1"/>
-          </a:fontRef>
-        </p:style>
         <p:txBody>
           <a:bodyPr rtlCol="0" anchor="ctr" wrap="square" lIns="73152" rIns="73152" tIns="27432" bIns="27432"/>
           <a:lstStyle/>
@@ -13301,20 +12095,6 @@
             <a:tailEnd type="triangle" w="med" len="med"/>
           </a:ln>
         </p:spPr>
-        <p:style>
-          <a:lnRef idx="2">
-            <a:schemeClr val="accent1"/>
-          </a:lnRef>
-          <a:fillRef idx="0">
-            <a:schemeClr val="accent1"/>
-          </a:fillRef>
-          <a:effectRef idx="1">
-            <a:schemeClr val="accent1"/>
-          </a:effectRef>
-          <a:fontRef idx="minor">
-            <a:schemeClr val="tx1"/>
-          </a:fontRef>
-        </p:style>
       </p:cxnSp>
       <p:sp>
         <p:nvSpPr>
@@ -13342,20 +12122,6 @@
           </a:ln>
           <a:effectLst/>
         </p:spPr>
-        <p:style>
-          <a:lnRef idx="1">
-            <a:schemeClr val="accent1"/>
-          </a:lnRef>
-          <a:fillRef idx="3">
-            <a:schemeClr val="accent1"/>
-          </a:fillRef>
-          <a:effectRef idx="2">
-            <a:schemeClr val="accent1"/>
-          </a:effectRef>
-          <a:fontRef idx="minor">
-            <a:schemeClr val="lt1"/>
-          </a:fontRef>
-        </p:style>
         <p:txBody>
           <a:bodyPr rtlCol="0" anchor="ctr" wrap="square" lIns="73152" rIns="73152" tIns="27432" bIns="27432"/>
           <a:lstStyle/>
@@ -13406,20 +12172,6 @@
             <a:tailEnd type="triangle" w="med" len="med"/>
           </a:ln>
         </p:spPr>
-        <p:style>
-          <a:lnRef idx="2">
-            <a:schemeClr val="accent1"/>
-          </a:lnRef>
-          <a:fillRef idx="0">
-            <a:schemeClr val="accent1"/>
-          </a:fillRef>
-          <a:effectRef idx="1">
-            <a:schemeClr val="accent1"/>
-          </a:effectRef>
-          <a:fontRef idx="minor">
-            <a:schemeClr val="tx1"/>
-          </a:fontRef>
-        </p:style>
       </p:cxnSp>
       <p:sp>
         <p:nvSpPr>
@@ -13447,20 +12199,6 @@
           </a:ln>
           <a:effectLst/>
         </p:spPr>
-        <p:style>
-          <a:lnRef idx="1">
-            <a:schemeClr val="accent1"/>
-          </a:lnRef>
-          <a:fillRef idx="3">
-            <a:schemeClr val="accent1"/>
-          </a:fillRef>
-          <a:effectRef idx="2">
-            <a:schemeClr val="accent1"/>
-          </a:effectRef>
-          <a:fontRef idx="minor">
-            <a:schemeClr val="lt1"/>
-          </a:fontRef>
-        </p:style>
         <p:txBody>
           <a:bodyPr rtlCol="0" anchor="ctr" wrap="square" lIns="73152" rIns="73152" tIns="27432" bIns="27432"/>
           <a:lstStyle/>
@@ -13511,20 +12249,6 @@
             <a:tailEnd type="triangle" w="med" len="med"/>
           </a:ln>
         </p:spPr>
-        <p:style>
-          <a:lnRef idx="2">
-            <a:schemeClr val="accent1"/>
-          </a:lnRef>
-          <a:fillRef idx="0">
-            <a:schemeClr val="accent1"/>
-          </a:fillRef>
-          <a:effectRef idx="1">
-            <a:schemeClr val="accent1"/>
-          </a:effectRef>
-          <a:fontRef idx="minor">
-            <a:schemeClr val="tx1"/>
-          </a:fontRef>
-        </p:style>
       </p:cxnSp>
       <p:sp>
         <p:nvSpPr>
@@ -13552,20 +12276,6 @@
           </a:ln>
           <a:effectLst/>
         </p:spPr>
-        <p:style>
-          <a:lnRef idx="1">
-            <a:schemeClr val="accent1"/>
-          </a:lnRef>
-          <a:fillRef idx="3">
-            <a:schemeClr val="accent1"/>
-          </a:fillRef>
-          <a:effectRef idx="2">
-            <a:schemeClr val="accent1"/>
-          </a:effectRef>
-          <a:fontRef idx="minor">
-            <a:schemeClr val="lt1"/>
-          </a:fontRef>
-        </p:style>
         <p:txBody>
           <a:bodyPr rtlCol="0" anchor="ctr" wrap="square" lIns="73152" rIns="73152" tIns="27432" bIns="27432"/>
           <a:lstStyle/>
@@ -13616,20 +12326,6 @@
             <a:tailEnd type="triangle" w="med" len="med"/>
           </a:ln>
         </p:spPr>
-        <p:style>
-          <a:lnRef idx="2">
-            <a:schemeClr val="accent1"/>
-          </a:lnRef>
-          <a:fillRef idx="0">
-            <a:schemeClr val="accent1"/>
-          </a:fillRef>
-          <a:effectRef idx="1">
-            <a:schemeClr val="accent1"/>
-          </a:effectRef>
-          <a:fontRef idx="minor">
-            <a:schemeClr val="tx1"/>
-          </a:fontRef>
-        </p:style>
       </p:cxnSp>
       <p:sp>
         <p:nvSpPr>
@@ -13657,20 +12353,6 @@
           </a:ln>
           <a:effectLst/>
         </p:spPr>
-        <p:style>
-          <a:lnRef idx="1">
-            <a:schemeClr val="accent1"/>
-          </a:lnRef>
-          <a:fillRef idx="3">
-            <a:schemeClr val="accent1"/>
-          </a:fillRef>
-          <a:effectRef idx="2">
-            <a:schemeClr val="accent1"/>
-          </a:effectRef>
-          <a:fontRef idx="minor">
-            <a:schemeClr val="lt1"/>
-          </a:fontRef>
-        </p:style>
         <p:txBody>
           <a:bodyPr rtlCol="0" anchor="ctr" wrap="square" lIns="73152" rIns="73152" tIns="27432" bIns="27432"/>
           <a:lstStyle/>
@@ -13730,7 +12412,7 @@
                 </a:solidFill>
                 <a:latin typeface="Arial"/>
               </a:rPr>
-              <a:t>Same score, different story - spatial-frequency features for AI-generated image detection</a:t>
+              <a:t>CSE 4883 Digital Image Processing  ·  Same score, different story</a:t>
             </a:r>
           </a:p>
         </p:txBody>
@@ -13814,7 +12496,7 @@
             <a:r>
               <a:rPr sz="1050" b="0" i="0">
                 <a:solidFill>
-                  <a:srgbClr val="A9B4C0"/>
+                  <a:srgbClr val="5D6D7E"/>
                 </a:solidFill>
                 <a:latin typeface="Arial"/>
               </a:rPr>
@@ -13849,7 +12531,7 @@
             <a:r>
               <a:rPr sz="1050" b="0" i="0">
                 <a:solidFill>
-                  <a:srgbClr val="A9B4C0"/>
+                  <a:srgbClr val="5D6D7E"/>
                 </a:solidFill>
                 <a:latin typeface="Arial"/>
               </a:rPr>
@@ -13884,7 +12566,7 @@
             <a:r>
               <a:rPr sz="1050" b="0" i="0">
                 <a:solidFill>
-                  <a:srgbClr val="A9B4C0"/>
+                  <a:srgbClr val="5D6D7E"/>
                 </a:solidFill>
                 <a:latin typeface="Arial"/>
               </a:rPr>
@@ -13949,20 +12631,6 @@
             <a:noFill/>
           </a:ln>
         </p:spPr>
-        <p:style>
-          <a:lnRef idx="1">
-            <a:schemeClr val="accent1"/>
-          </a:lnRef>
-          <a:fillRef idx="3">
-            <a:schemeClr val="accent1"/>
-          </a:fillRef>
-          <a:effectRef idx="2">
-            <a:schemeClr val="accent1"/>
-          </a:effectRef>
-          <a:fontRef idx="minor">
-            <a:schemeClr val="lt1"/>
-          </a:fontRef>
-        </p:style>
         <p:txBody>
           <a:bodyPr rtlCol="0" anchor="ctr"/>
           <a:lstStyle/>
@@ -13997,7 +12665,7 @@
             <a:r>
               <a:rPr sz="1050" b="0" i="0">
                 <a:solidFill>
-                  <a:srgbClr val="A9B4C0"/>
+                  <a:srgbClr val="5D6D7E"/>
                 </a:solidFill>
                 <a:latin typeface="Arial"/>
               </a:rPr>
@@ -14032,7 +12700,7 @@
             <a:r>
               <a:rPr sz="1050" b="0" i="0">
                 <a:solidFill>
-                  <a:srgbClr val="A9B4C0"/>
+                  <a:srgbClr val="5D6D7E"/>
                 </a:solidFill>
                 <a:latin typeface="Arial"/>
               </a:rPr>
@@ -14067,7 +12735,7 @@
             <a:r>
               <a:rPr sz="1050" b="0" i="0">
                 <a:solidFill>
-                  <a:srgbClr val="A9B4C0"/>
+                  <a:srgbClr val="5D6D7E"/>
                 </a:solidFill>
                 <a:latin typeface="Arial"/>
               </a:rPr>
@@ -14097,20 +12765,6 @@
             <a:noFill/>
           </a:ln>
         </p:spPr>
-        <p:style>
-          <a:lnRef idx="1">
-            <a:schemeClr val="accent1"/>
-          </a:lnRef>
-          <a:fillRef idx="3">
-            <a:schemeClr val="accent1"/>
-          </a:fillRef>
-          <a:effectRef idx="2">
-            <a:schemeClr val="accent1"/>
-          </a:effectRef>
-          <a:fontRef idx="minor">
-            <a:schemeClr val="lt1"/>
-          </a:fontRef>
-        </p:style>
         <p:txBody>
           <a:bodyPr rtlCol="0" anchor="ctr"/>
           <a:lstStyle/>
@@ -14128,7 +12782,7 @@
         <p:spPr>
           <a:xfrm>
             <a:off x="548640" y="713232"/>
-            <a:ext cx="9509760" cy="548640"/>
+            <a:ext cx="9418320" cy="548640"/>
           </a:xfrm>
           <a:prstGeom prst="rect">
             <a:avLst/>
@@ -14162,8 +12816,8 @@
         </p:nvSpPr>
         <p:spPr>
           <a:xfrm>
-            <a:off x="9997135" y="822960"/>
-            <a:ext cx="1645920" cy="274320"/>
+            <a:off x="10271455" y="822960"/>
+            <a:ext cx="1371600" cy="274320"/>
           </a:xfrm>
           <a:prstGeom prst="rect">
             <a:avLst/>
@@ -15096,20 +13750,6 @@
           </a:ln>
           <a:effectLst/>
         </p:spPr>
-        <p:style>
-          <a:lnRef idx="1">
-            <a:schemeClr val="accent1"/>
-          </a:lnRef>
-          <a:fillRef idx="3">
-            <a:schemeClr val="accent1"/>
-          </a:fillRef>
-          <a:effectRef idx="2">
-            <a:schemeClr val="accent1"/>
-          </a:effectRef>
-          <a:fontRef idx="minor">
-            <a:schemeClr val="lt1"/>
-          </a:fontRef>
-        </p:style>
         <p:txBody>
           <a:bodyPr rtlCol="0" anchor="ctr" wrap="square" lIns="73152" rIns="73152" tIns="27432" bIns="27432"/>
           <a:lstStyle/>
@@ -15160,20 +13800,6 @@
             <a:tailEnd type="triangle" w="med" len="med"/>
           </a:ln>
         </p:spPr>
-        <p:style>
-          <a:lnRef idx="2">
-            <a:schemeClr val="accent1"/>
-          </a:lnRef>
-          <a:fillRef idx="0">
-            <a:schemeClr val="accent1"/>
-          </a:fillRef>
-          <a:effectRef idx="1">
-            <a:schemeClr val="accent1"/>
-          </a:effectRef>
-          <a:fontRef idx="minor">
-            <a:schemeClr val="tx1"/>
-          </a:fontRef>
-        </p:style>
       </p:cxnSp>
       <p:sp>
         <p:nvSpPr>
@@ -15201,20 +13827,6 @@
           </a:ln>
           <a:effectLst/>
         </p:spPr>
-        <p:style>
-          <a:lnRef idx="1">
-            <a:schemeClr val="accent1"/>
-          </a:lnRef>
-          <a:fillRef idx="3">
-            <a:schemeClr val="accent1"/>
-          </a:fillRef>
-          <a:effectRef idx="2">
-            <a:schemeClr val="accent1"/>
-          </a:effectRef>
-          <a:fontRef idx="minor">
-            <a:schemeClr val="lt1"/>
-          </a:fontRef>
-        </p:style>
         <p:txBody>
           <a:bodyPr rtlCol="0" anchor="ctr" wrap="square" lIns="73152" rIns="73152" tIns="27432" bIns="27432"/>
           <a:lstStyle/>
@@ -15265,20 +13877,6 @@
             <a:tailEnd type="triangle" w="med" len="med"/>
           </a:ln>
         </p:spPr>
-        <p:style>
-          <a:lnRef idx="2">
-            <a:schemeClr val="accent1"/>
-          </a:lnRef>
-          <a:fillRef idx="0">
-            <a:schemeClr val="accent1"/>
-          </a:fillRef>
-          <a:effectRef idx="1">
-            <a:schemeClr val="accent1"/>
-          </a:effectRef>
-          <a:fontRef idx="minor">
-            <a:schemeClr val="tx1"/>
-          </a:fontRef>
-        </p:style>
       </p:cxnSp>
       <p:sp>
         <p:nvSpPr>
@@ -15306,20 +13904,6 @@
           </a:ln>
           <a:effectLst/>
         </p:spPr>
-        <p:style>
-          <a:lnRef idx="1">
-            <a:schemeClr val="accent1"/>
-          </a:lnRef>
-          <a:fillRef idx="3">
-            <a:schemeClr val="accent1"/>
-          </a:fillRef>
-          <a:effectRef idx="2">
-            <a:schemeClr val="accent1"/>
-          </a:effectRef>
-          <a:fontRef idx="minor">
-            <a:schemeClr val="lt1"/>
-          </a:fontRef>
-        </p:style>
         <p:txBody>
           <a:bodyPr rtlCol="0" anchor="ctr" wrap="square" lIns="73152" rIns="73152" tIns="27432" bIns="27432"/>
           <a:lstStyle/>
@@ -15383,7 +13967,7 @@
                 </a:solidFill>
                 <a:latin typeface="Arial"/>
               </a:rPr>
-              <a:t>E1-E5 were fixed in advance.</a:t>
+              <a:t>E1–E5 were fixed in advance.</a:t>
             </a:r>
           </a:p>
           <a:p>
@@ -15450,7 +14034,7 @@
                 </a:solidFill>
                 <a:latin typeface="Arial"/>
               </a:rPr>
-              <a:t>Same score, different story - spatial-frequency features for AI-generated image detection</a:t>
+              <a:t>CSE 4883 Digital Image Processing  ·  Same score, different story</a:t>
             </a:r>
           </a:p>
         </p:txBody>
@@ -15534,7 +14118,7 @@
             <a:r>
               <a:rPr sz="1050" b="0" i="0">
                 <a:solidFill>
-                  <a:srgbClr val="A9B4C0"/>
+                  <a:srgbClr val="5D6D7E"/>
                 </a:solidFill>
                 <a:latin typeface="Arial"/>
               </a:rPr>
@@ -15569,7 +14153,7 @@
             <a:r>
               <a:rPr sz="1050" b="0" i="0">
                 <a:solidFill>
-                  <a:srgbClr val="A9B4C0"/>
+                  <a:srgbClr val="5D6D7E"/>
                 </a:solidFill>
                 <a:latin typeface="Arial"/>
               </a:rPr>
@@ -15604,7 +14188,7 @@
             <a:r>
               <a:rPr sz="1050" b="0" i="0">
                 <a:solidFill>
-                  <a:srgbClr val="A9B4C0"/>
+                  <a:srgbClr val="5D6D7E"/>
                 </a:solidFill>
                 <a:latin typeface="Arial"/>
               </a:rPr>
@@ -15639,7 +14223,7 @@
             <a:r>
               <a:rPr sz="1050" b="0" i="0">
                 <a:solidFill>
-                  <a:srgbClr val="A9B4C0"/>
+                  <a:srgbClr val="5D6D7E"/>
                 </a:solidFill>
                 <a:latin typeface="Arial"/>
               </a:rPr>
@@ -15704,20 +14288,6 @@
             <a:noFill/>
           </a:ln>
         </p:spPr>
-        <p:style>
-          <a:lnRef idx="1">
-            <a:schemeClr val="accent1"/>
-          </a:lnRef>
-          <a:fillRef idx="3">
-            <a:schemeClr val="accent1"/>
-          </a:fillRef>
-          <a:effectRef idx="2">
-            <a:schemeClr val="accent1"/>
-          </a:effectRef>
-          <a:fontRef idx="minor">
-            <a:schemeClr val="lt1"/>
-          </a:fontRef>
-        </p:style>
         <p:txBody>
           <a:bodyPr rtlCol="0" anchor="ctr"/>
           <a:lstStyle/>
@@ -15752,7 +14322,7 @@
             <a:r>
               <a:rPr sz="1050" b="0" i="0">
                 <a:solidFill>
-                  <a:srgbClr val="A9B4C0"/>
+                  <a:srgbClr val="5D6D7E"/>
                 </a:solidFill>
                 <a:latin typeface="Arial"/>
               </a:rPr>
@@ -15787,7 +14357,7 @@
             <a:r>
               <a:rPr sz="1050" b="0" i="0">
                 <a:solidFill>
-                  <a:srgbClr val="A9B4C0"/>
+                  <a:srgbClr val="5D6D7E"/>
                 </a:solidFill>
                 <a:latin typeface="Arial"/>
               </a:rPr>
@@ -15817,20 +14387,6 @@
             <a:noFill/>
           </a:ln>
         </p:spPr>
-        <p:style>
-          <a:lnRef idx="1">
-            <a:schemeClr val="accent1"/>
-          </a:lnRef>
-          <a:fillRef idx="3">
-            <a:schemeClr val="accent1"/>
-          </a:fillRef>
-          <a:effectRef idx="2">
-            <a:schemeClr val="accent1"/>
-          </a:effectRef>
-          <a:fontRef idx="minor">
-            <a:schemeClr val="lt1"/>
-          </a:fontRef>
-        </p:style>
         <p:txBody>
           <a:bodyPr rtlCol="0" anchor="ctr"/>
           <a:lstStyle/>
@@ -15848,7 +14404,7 @@
         <p:spPr>
           <a:xfrm>
             <a:off x="548640" y="713232"/>
-            <a:ext cx="9509760" cy="548640"/>
+            <a:ext cx="9418320" cy="548640"/>
           </a:xfrm>
           <a:prstGeom prst="rect">
             <a:avLst/>
@@ -15869,7 +14425,7 @@
                 </a:solidFill>
                 <a:latin typeface="Georgia"/>
               </a:rPr>
-              <a:t>Results: combined wins pooled - not everywhere</a:t>
+              <a:t>Results: combined wins pooled — not everywhere</a:t>
             </a:r>
           </a:p>
         </p:txBody>
@@ -15882,8 +14438,8 @@
         </p:nvSpPr>
         <p:spPr>
           <a:xfrm>
-            <a:off x="9997135" y="822960"/>
-            <a:ext cx="1645920" cy="274320"/>
+            <a:off x="10271455" y="822960"/>
+            <a:ext cx="1371600" cy="274320"/>
           </a:xfrm>
           <a:prstGeom prst="rect">
             <a:avLst/>
@@ -15984,7 +14540,7 @@
             <a:r>
               <a:rPr sz="1200" b="0" i="0">
                 <a:solidFill>
-                  <a:srgbClr val="8A97A5"/>
+                  <a:srgbClr val="5D6D7E"/>
                 </a:solidFill>
                 <a:latin typeface="Arial"/>
               </a:rPr>
@@ -16037,7 +14593,7 @@
         <p:spPr>
           <a:xfrm>
             <a:off x="7589520" y="1920240"/>
-            <a:ext cx="2743200" cy="320040"/>
+            <a:ext cx="2560320" cy="320040"/>
           </a:xfrm>
           <a:prstGeom prst="rect">
             <a:avLst/>
@@ -16107,7 +14663,7 @@
         <p:spPr>
           <a:xfrm>
             <a:off x="7589520" y="2395728"/>
-            <a:ext cx="2743200" cy="320040"/>
+            <a:ext cx="2560320" cy="320040"/>
           </a:xfrm>
           <a:prstGeom prst="rect">
             <a:avLst/>
@@ -16177,7 +14733,7 @@
         <p:spPr>
           <a:xfrm>
             <a:off x="7589520" y="2871216"/>
-            <a:ext cx="2743200" cy="320040"/>
+            <a:ext cx="2560320" cy="320040"/>
           </a:xfrm>
           <a:prstGeom prst="rect">
             <a:avLst/>
@@ -16198,7 +14754,7 @@
                 </a:solidFill>
                 <a:latin typeface="Arial"/>
               </a:rPr>
-              <a:t>Shuffled labels (x200)</a:t>
+              <a:t>Shuffled labels (×200)</a:t>
             </a:r>
           </a:p>
         </p:txBody>
@@ -16233,7 +14789,7 @@
                 </a:solidFill>
                 <a:latin typeface="Arial"/>
               </a:rPr>
-              <a:t>0.50-0.52</a:t>
+              <a:t>0.50–0.52</a:t>
             </a:r>
           </a:p>
         </p:txBody>
@@ -16247,7 +14803,7 @@
         <p:spPr>
           <a:xfrm>
             <a:off x="7589520" y="3346704"/>
-            <a:ext cx="2743200" cy="320040"/>
+            <a:ext cx="2560320" cy="320040"/>
           </a:xfrm>
           <a:prstGeom prst="rect">
             <a:avLst/>
@@ -16488,7 +15044,7 @@
                           </a:solidFill>
                           <a:latin typeface="Arial"/>
                         </a:rPr>
-                        <a:t>-0.078</a:t>
+                        <a:t>−0.078</a:t>
                       </a:r>
                     </a:p>
                   </a:txBody>
@@ -16538,7 +15094,7 @@
                 </a:solidFill>
                 <a:latin typeface="Arial"/>
               </a:rPr>
-              <a:t>Same score, different story - spatial-frequency features for AI-generated image detection</a:t>
+              <a:t>CSE 4883 Digital Image Processing  ·  Same score, different story</a:t>
             </a:r>
           </a:p>
         </p:txBody>
@@ -16622,7 +15178,7 @@
             <a:r>
               <a:rPr sz="1050" b="0" i="0">
                 <a:solidFill>
-                  <a:srgbClr val="A9B4C0"/>
+                  <a:srgbClr val="5D6D7E"/>
                 </a:solidFill>
                 <a:latin typeface="Arial"/>
               </a:rPr>
@@ -16657,7 +15213,7 @@
             <a:r>
               <a:rPr sz="1050" b="0" i="0">
                 <a:solidFill>
-                  <a:srgbClr val="A9B4C0"/>
+                  <a:srgbClr val="5D6D7E"/>
                 </a:solidFill>
                 <a:latin typeface="Arial"/>
               </a:rPr>
@@ -16692,7 +15248,7 @@
             <a:r>
               <a:rPr sz="1050" b="0" i="0">
                 <a:solidFill>
-                  <a:srgbClr val="A9B4C0"/>
+                  <a:srgbClr val="5D6D7E"/>
                 </a:solidFill>
                 <a:latin typeface="Arial"/>
               </a:rPr>
@@ -16727,7 +15283,7 @@
             <a:r>
               <a:rPr sz="1050" b="0" i="0">
                 <a:solidFill>
-                  <a:srgbClr val="A9B4C0"/>
+                  <a:srgbClr val="5D6D7E"/>
                 </a:solidFill>
                 <a:latin typeface="Arial"/>
               </a:rPr>
@@ -16792,20 +15348,6 @@
             <a:noFill/>
           </a:ln>
         </p:spPr>
-        <p:style>
-          <a:lnRef idx="1">
-            <a:schemeClr val="accent1"/>
-          </a:lnRef>
-          <a:fillRef idx="3">
-            <a:schemeClr val="accent1"/>
-          </a:fillRef>
-          <a:effectRef idx="2">
-            <a:schemeClr val="accent1"/>
-          </a:effectRef>
-          <a:fontRef idx="minor">
-            <a:schemeClr val="lt1"/>
-          </a:fontRef>
-        </p:style>
         <p:txBody>
           <a:bodyPr rtlCol="0" anchor="ctr"/>
           <a:lstStyle/>
@@ -16840,7 +15382,7 @@
             <a:r>
               <a:rPr sz="1050" b="0" i="0">
                 <a:solidFill>
-                  <a:srgbClr val="A9B4C0"/>
+                  <a:srgbClr val="5D6D7E"/>
                 </a:solidFill>
                 <a:latin typeface="Arial"/>
               </a:rPr>
@@ -16875,7 +15417,7 @@
             <a:r>
               <a:rPr sz="1050" b="0" i="0">
                 <a:solidFill>
-                  <a:srgbClr val="A9B4C0"/>
+                  <a:srgbClr val="5D6D7E"/>
                 </a:solidFill>
                 <a:latin typeface="Arial"/>
               </a:rPr>
@@ -16905,20 +15447,6 @@
             <a:noFill/>
           </a:ln>
         </p:spPr>
-        <p:style>
-          <a:lnRef idx="1">
-            <a:schemeClr val="accent1"/>
-          </a:lnRef>
-          <a:fillRef idx="3">
-            <a:schemeClr val="accent1"/>
-          </a:fillRef>
-          <a:effectRef idx="2">
-            <a:schemeClr val="accent1"/>
-          </a:effectRef>
-          <a:fontRef idx="minor">
-            <a:schemeClr val="lt1"/>
-          </a:fontRef>
-        </p:style>
         <p:txBody>
           <a:bodyPr rtlCol="0" anchor="ctr"/>
           <a:lstStyle/>
@@ -16936,7 +15464,7 @@
         <p:spPr>
           <a:xfrm>
             <a:off x="548640" y="713232"/>
-            <a:ext cx="9509760" cy="548640"/>
+            <a:ext cx="9418320" cy="548640"/>
           </a:xfrm>
           <a:prstGeom prst="rect">
             <a:avLst/>
@@ -16970,8 +15498,8 @@
         </p:nvSpPr>
         <p:spPr>
           <a:xfrm>
-            <a:off x="9997135" y="822960"/>
-            <a:ext cx="1645920" cy="274320"/>
+            <a:off x="10271455" y="822960"/>
+            <a:ext cx="1371600" cy="274320"/>
           </a:xfrm>
           <a:prstGeom prst="rect">
             <a:avLst/>
@@ -17072,7 +15600,7 @@
             <a:r>
               <a:rPr sz="1200" b="0" i="0">
                 <a:solidFill>
-                  <a:srgbClr val="8A97A5"/>
+                  <a:srgbClr val="5D6D7E"/>
                 </a:solidFill>
                 <a:latin typeface="Arial"/>
               </a:rPr>
@@ -17111,7 +15639,7 @@
                 </a:solidFill>
                 <a:latin typeface="Arial"/>
               </a:rPr>
-              <a:t>Same score, different story - spatial-frequency features for AI-generated image detection</a:t>
+              <a:t>CSE 4883 Digital Image Processing  ·  Same score, different story</a:t>
             </a:r>
           </a:p>
         </p:txBody>

</xml_diff>